<commit_message>
Refresh submission: regenerate deck, add presentation skill, clean up
Add .cursor/skills/presentation (builds deck on official UiPath template); regenerate deck + PDF from verified context; update README; remove stale forum-post.md and superseded build script.

Co-authored-by: Cursor <cursoragent@cursor.com>
</commit_message>
<xml_diff>
--- a/submission/deck/Submission-Template-Deal-Desk-Agent.pptx
+++ b/submission/deck/Submission-Template-Deal-Desk-Agent.pptx
@@ -12588,7 +12588,7 @@
               <a:rPr sz="1800" b="1">
                 <a:latin typeface="Segoe UI"/>
               </a:rPr>
-              <a:t>LangGraph coded agent</a:t>
+              <a:t>Coded Agents (LangGraph)</a:t>
             </a:r>
           </a:p>
         </p:txBody>
@@ -12775,7 +12775,7 @@
               <a:rPr sz="1300" b="0">
                 <a:latin typeface="Segoe UI"/>
               </a:rPr>
-              <a:t>plan / render / process_response (Python LangGraph)</a:t>
+              <a:t>plan / render / process_response (Python)</a:t>
             </a:r>
           </a:p>
         </p:txBody>
@@ -13199,7 +13199,7 @@
               <a:rPr sz="1300" b="0">
                 <a:latin typeface="Segoe UI"/>
               </a:rPr>
-              <a:t>orchestration, gateway, sequential loop, polling</a:t>
+              <a:t>orchestration, gateway, sequential loop</a:t>
             </a:r>
           </a:p>
         </p:txBody>
@@ -13623,7 +13623,7 @@
               <a:rPr sz="1300" b="0">
                 <a:latin typeface="Segoe UI"/>
               </a:rPr>
-              <a:t>RPA: POSTs to HITL portal, sends Outlook email</a:t>
+              <a:t>RPA: 3 channels + UiPath.Persistence wait</a:t>
             </a:r>
           </a:p>
         </p:txBody>
@@ -13892,7 +13892,7 @@
           <a:p>
             <a:pPr algn="l"/>
             <a:r>
-              <a:rPr sz="1600" b="1">
+              <a:rPr sz="1600" b="0">
                 <a:latin typeface="Segoe UI"/>
               </a:rPr>
               <a:t>Track 2: UiPath Maestro BPMN</a:t>
@@ -14074,7 +14074,7 @@
               <a:rPr sz="1300" b="0">
                 <a:latin typeface="Segoe UI"/>
               </a:rPr>
-              <a:t>Every sales org has a Deal Desk: the person who reviews discount requests,</a:t>
+              <a:t>Every sales org has a Deal Desk: the team that reviews pricing exceptions,</a:t>
             </a:r>
           </a:p>
           <a:p>
@@ -14083,7 +14083,7 @@
               <a:rPr sz="1300" b="0">
                 <a:latin typeface="Segoe UI"/>
               </a:rPr>
-              <a:t>emails managers up the chain, waits for replies, and updates the CRM.</a:t>
+              <a:t>emails managers up the chain, waits for replies, consolidates decisions,</a:t>
             </a:r>
           </a:p>
           <a:p>
@@ -14092,20 +14092,11 @@
               <a:rPr sz="1300" b="0">
                 <a:latin typeface="Segoe UI"/>
               </a:rPr>
-              <a:t>It is entirely manual, inbox-driven, and slower than the sales team needs.</a:t>
+              <a:t>and updates the CRM. It is manual, inbox-driven, and slow.</a:t>
             </a:r>
           </a:p>
           <a:p>
             <a:pPr algn="l"/>
-          </a:p>
-          <a:p>
-            <a:pPr algn="l"/>
-            <a:r>
-              <a:rPr sz="1300" b="0">
-                <a:latin typeface="Segoe UI"/>
-              </a:rPr>
-              <a:t>The Opportunity Owner (AE) submits a request and then waits:</a:t>
-            </a:r>
           </a:p>
           <a:p>
             <a:pPr algn="l"/>
@@ -14193,7 +14184,7 @@
               <a:rPr sz="1250" b="0">
                 <a:latin typeface="Segoe UI"/>
               </a:rPr>
-              <a:t>The Deal Desk Agent does the Deal Desk job:</a:t>
+              <a:t>The Deal Desk Agent does that job, end to end on Automation Cloud:</a:t>
             </a:r>
           </a:p>
           <a:p>
@@ -14205,7 +14196,7 @@
               <a:rPr sz="1250" b="0">
                 <a:latin typeface="Segoe UI"/>
               </a:rPr>
-              <a:t>  1. Queries live Salesforce data via AgentHub MCP sidecar.</a:t>
+              <a:t>  1. Live Salesforce data via AgentHub MCP; approver chain from the org chart.</a:t>
             </a:r>
           </a:p>
           <a:p>
@@ -14214,7 +14205,7 @@
               <a:rPr sz="1250" b="0">
                 <a:latin typeface="Segoe UI"/>
               </a:rPr>
-              <a:t>  2. Resolves approver chain from HiBob org chart (reportsTo hierarchy).</a:t>
+              <a:t>  2. Risk scoring + LLM rationale -&gt; recommendation and disposition.</a:t>
             </a:r>
           </a:p>
           <a:p>
@@ -14223,7 +14214,7 @@
               <a:rPr sz="1250" b="0">
                 <a:latin typeface="Segoe UI"/>
               </a:rPr>
-              <a:t>  3. Applies risk scoring + LLM reasoning to draft a recommendation.</a:t>
+              <a:t>  3. Low-risk deals auto-approve with zero human touch.</a:t>
             </a:r>
           </a:p>
           <a:p>
@@ -14232,7 +14223,7 @@
               <a:rPr sz="1250" b="0">
                 <a:latin typeface="Segoe UI"/>
               </a:rPr>
-              <a:t>  4. WaitDecision Robot: Action Center task + Outlook Adaptive Card + Slack DM</a:t>
+              <a:t>  4. WaitDecision Robot reaches each approver on 3 channels at once:</a:t>
             </a:r>
           </a:p>
           <a:p>
@@ -14241,7 +14232,7 @@
               <a:rPr sz="1250" b="0">
                 <a:latin typeface="Segoe UI"/>
               </a:rPr>
-              <a:t>     — three channels simultaneously. Robot suspends via UiPath Persistence.</a:t>
+              <a:t>     Outlook Adaptive Card + Slack DM + Action Center 'wait for task'.</a:t>
             </a:r>
           </a:p>
           <a:p>
@@ -14250,7 +14241,7 @@
               <a:rPr sz="1250" b="0">
                 <a:latin typeface="Segoe UI"/>
               </a:rPr>
-              <a:t>  5. Approver decides in Outlook (Adaptive Card button) or Action Center.</a:t>
+              <a:t>  5. AWS Lambda HITL bridge mints a token; any channel resolves the wait.</a:t>
             </a:r>
           </a:p>
           <a:p>
@@ -14259,7 +14250,7 @@
               <a:rPr sz="1250" b="0">
                 <a:latin typeface="Segoe UI"/>
               </a:rPr>
-              <a:t>  6. Robot resumes, returns decision to BPMN. Rejection short-circuits chain.</a:t>
+              <a:t>  6. process_response interprets decisions; rejection short-circuits the chain.</a:t>
             </a:r>
           </a:p>
           <a:p>
@@ -14268,7 +14259,7 @@
               <a:rPr sz="1250" b="0">
                 <a:latin typeface="Segoe UI"/>
               </a:rPr>
-              <a:t>  7. Slack + Outlook summary to AE. Data Fabric audit record.</a:t>
+              <a:t>  7. Slack + Outlook summary to the AE; Data Fabric ApprovalAudit record.</a:t>
             </a:r>
           </a:p>
         </p:txBody>
@@ -16154,7 +16145,7 @@
               <a:rPr sz="1200" b="0">
                 <a:latin typeface="Segoe UI"/>
               </a:rPr>
-              <a:t>For the Opportunity Owner (AE / requester):</a:t>
+              <a:t>For the Opportunity Owner (AE):</a:t>
             </a:r>
           </a:p>
           <a:p>
@@ -16163,7 +16154,7 @@
               <a:rPr sz="1200" b="0">
                 <a:latin typeface="Segoe UI"/>
               </a:rPr>
-              <a:t>  - No more chasing managers: agent routes, robot sends, BPMN tracks.</a:t>
+              <a:t>  - No chasing managers: agent routes, robot sends, BPMN tracks.</a:t>
             </a:r>
           </a:p>
           <a:p>
@@ -16172,7 +16163,7 @@
               <a:rPr sz="1200" b="0">
                 <a:latin typeface="Segoe UI"/>
               </a:rPr>
-              <a:t>  - Slack DM + Outlook summary with full decision trail on completion.</a:t>
+              <a:t>  - Slack DM + Outlook summary with the full decision trail at the end.</a:t>
             </a:r>
           </a:p>
           <a:p>
@@ -16181,7 +16172,7 @@
               <a:rPr sz="1200" b="0">
                 <a:latin typeface="Segoe UI"/>
               </a:rPr>
-              <a:t>  - Low-risk deals (&lt;=5% discount / &lt;=$50k) clear with ZERO human touch.</a:t>
+              <a:t>  - Low-risk deals (&lt;=5% / &lt;=$50k) clear with ZERO human touch.</a:t>
             </a:r>
           </a:p>
           <a:p>
@@ -16202,7 +16193,7 @@
               <a:rPr sz="1200" b="0">
                 <a:latin typeface="Segoe UI"/>
               </a:rPr>
-              <a:t>  - Consistent policy applied identically to every deal (risk score formula).</a:t>
+              <a:t>  - Consistent policy applied identically via the risk-score formula.</a:t>
             </a:r>
           </a:p>
           <a:p>
@@ -16211,7 +16202,7 @@
               <a:rPr sz="1200" b="0">
                 <a:latin typeface="Segoe UI"/>
               </a:rPr>
-              <a:t>  - SLA: BPMN polls every 30s; timer fires reminder via Robot if silent.</a:t>
+              <a:t>  - Rejection short-circuits the chain (no wasted approver time).</a:t>
             </a:r>
           </a:p>
           <a:p>
@@ -16220,16 +16211,7 @@
               <a:rPr sz="1200" b="0">
                 <a:latin typeface="Segoe UI"/>
               </a:rPr>
-              <a:t>  - Rejection short-circuits chain immediately (no wasted approver time).</a:t>
-            </a:r>
-          </a:p>
-          <a:p>
-            <a:pPr algn="l"/>
-            <a:r>
-              <a:rPr sz="1200" b="0">
-                <a:latin typeface="Segoe UI"/>
-              </a:rPr>
-              <a:t>  - Audit: Data Fabric logs agent recommendation vs. each human decision.</a:t>
+              <a:t>  - Data Fabric logs the agent recommendation vs. each human decision.</a:t>
             </a:r>
           </a:p>
         </p:txBody>
@@ -16419,7 +16401,7 @@
               <a:rPr sz="1150" b="1">
                 <a:latin typeface="Segoe UI"/>
               </a:rPr>
-              <a:t>Technologies (all verified live Jun 22 2026):</a:t>
+              <a:t>Technologies (verified live Jun 22 2026):</a:t>
             </a:r>
           </a:p>
           <a:p>
@@ -16428,7 +16410,7 @@
               <a:rPr sz="1150" b="0">
                 <a:latin typeface="Segoe UI"/>
               </a:rPr>
-              <a:t>  UiPath Coded Agents (Python + LangGraph): plan, render, process_response</a:t>
+              <a:t>  Coded Agents (Python + LangGraph): plan, render, process_response</a:t>
             </a:r>
           </a:p>
           <a:p>
@@ -16437,7 +16419,7 @@
               <a:rPr sz="1150" b="0">
                 <a:latin typeface="Segoe UI"/>
               </a:rPr>
-              <a:t>  UiPath Maestro BPMN 2.0: sequential multi-instance loop, completionCondition</a:t>
+              <a:t>  Maestro BPMN 2.0: sequential multi-instance loop, completionCondition</a:t>
             </a:r>
           </a:p>
           <a:p>
@@ -16446,7 +16428,7 @@
               <a:rPr sz="1150" b="0">
                 <a:latin typeface="Segoe UI"/>
               </a:rPr>
-              <a:t>  WaitDecision Robot v1.3.16 (UiPath RPA + Persistence.Activities): all channels</a:t>
+              <a:t>  WaitDecision Robot (UiPath RPA + Persistence): all three channels</a:t>
             </a:r>
           </a:p>
           <a:p>
@@ -16455,7 +16437,7 @@
               <a:rPr sz="1150" b="0">
                 <a:latin typeface="Segoe UI"/>
               </a:rPr>
-              <a:t>  Action Center: external task in Deal Desk catalog, Approve/Reject buttons</a:t>
+              <a:t>  Action Center: external task 'wait for task' (Deal Desk catalog)</a:t>
             </a:r>
           </a:p>
           <a:p>
@@ -16473,7 +16455,7 @@
               <a:rPr sz="1150" b="0">
                 <a:latin typeface="Segoe UI"/>
               </a:rPr>
-              <a:t>  Slack Block Kit: DM to approver + requester via Slack Bot Token</a:t>
+              <a:t>  Slack Block Kit: DM to approver + requester</a:t>
             </a:r>
           </a:p>
           <a:p>
@@ -16482,7 +16464,7 @@
               <a:rPr sz="1150" b="0">
                 <a:latin typeface="Segoe UI"/>
               </a:rPr>
-              <a:t>  AgentHub MCP Server: Salesforce DealDesk MCP (live IS, read-only SOQL)</a:t>
+              <a:t>  AWS Lambda + CloudFront: HITL bridge for the approval loop</a:t>
             </a:r>
           </a:p>
           <a:p>
@@ -16491,7 +16473,7 @@
               <a:rPr sz="1150" b="0">
                 <a:latin typeface="Segoe UI"/>
               </a:rPr>
-              <a:t>  Data Fabric: ApprovalAudit entity (agent rec vs. each human decision)</a:t>
+              <a:t>  AgentHub MCP: Salesforce DealDesk MCP (live IS, read-only SOQL)</a:t>
             </a:r>
           </a:p>
           <a:p>
@@ -16500,7 +16482,7 @@
               <a:rPr sz="1150" b="0">
                 <a:latin typeface="Segoe UI"/>
               </a:rPr>
-              <a:t>  Solution deployed to Shared/DealDeskApprovalGlobal on Automation Cloud</a:t>
+              <a:t>  Data Fabric: ApprovalAudit; deployed to Shared/DealDeskApprovalGlobal</a:t>
             </a:r>
           </a:p>
         </p:txBody>
@@ -17313,7 +17295,7 @@
               <a:rPr sz="1000" b="0">
                 <a:latin typeface="Segoe UI"/>
               </a:rPr>
-              <a:t>  AgentHub MCP sidecar queries live Salesforce Opportunity + Account data</a:t>
+              <a:t>  AgentHub MCP queries live Salesforce; org chart -&gt; approver chain</a:t>
             </a:r>
           </a:p>
           <a:p>
@@ -17322,16 +17304,7 @@
               <a:rPr sz="1000" b="0">
                 <a:latin typeface="Segoe UI"/>
               </a:rPr>
-              <a:t>  HiBob org chart resolution -&gt; builds approver chain (manager-&gt;director-&gt;vp-&gt;cfo-&gt;cro)</a:t>
-            </a:r>
-          </a:p>
-          <a:p>
-            <a:pPr algn="l"/>
-            <a:r>
-              <a:rPr sz="1000" b="0">
-                <a:latin typeface="Segoe UI"/>
-              </a:rPr>
-              <a:t>  risk_score formula + LLM reasoning -&gt; RoutingPlan (disposition + rationale + chain)</a:t>
+              <a:t>  risk_score + LLM reasoning -&gt; RoutingPlan (disposition + rationale + chain)</a:t>
             </a:r>
           </a:p>
           <a:p>
@@ -17352,7 +17325,7 @@
               <a:rPr sz="1000" b="0">
                 <a:latin typeface="Segoe UI"/>
               </a:rPr>
-              <a:t>  auto_approve  -&gt;  Slack + Outlook to AE + Data Fabric audit  (zero human touch)</a:t>
+              <a:t>  auto_approve   -&gt; Slack + Outlook to AE + Data Fabric audit (zero touch)</a:t>
             </a:r>
           </a:p>
           <a:p>
@@ -17361,7 +17334,7 @@
               <a:rPr sz="1000" b="0">
                 <a:latin typeface="Segoe UI"/>
               </a:rPr>
-              <a:t>  exception     -&gt;  immediate human review</a:t>
+              <a:t>  exception      -&gt; immediate human review</a:t>
             </a:r>
           </a:p>
           <a:p>
@@ -17370,7 +17343,7 @@
               <a:rPr sz="1000" b="0">
                 <a:latin typeface="Segoe UI"/>
               </a:rPr>
-              <a:t>  needs_approval  -&gt;  sequential approver loop (per-approver):</a:t>
+              <a:t>  needs_approval -&gt; sequential approver loop (per approver):</a:t>
             </a:r>
           </a:p>
           <a:p>
@@ -17379,7 +17352,7 @@
               <a:rPr sz="1000" b="0">
                 <a:latin typeface="Segoe UI"/>
               </a:rPr>
-              <a:t>    render agent builds Adaptive Card payload (deal context + LLM recommendation)</a:t>
+              <a:t>    render agent builds the approval payload</a:t>
             </a:r>
           </a:p>
           <a:p>
@@ -17388,7 +17361,7 @@
               <a:rPr sz="1000" b="0">
                 <a:latin typeface="Segoe UI"/>
               </a:rPr>
-              <a:t>    WaitDecision Robot v1.3.16:</a:t>
+              <a:t>    WaitDecision Robot: Outlook Adaptive Card + Slack DM + Action Center task</a:t>
             </a:r>
           </a:p>
           <a:p>
@@ -17397,7 +17370,7 @@
               <a:rPr sz="1000" b="0">
                 <a:latin typeface="Segoe UI"/>
               </a:rPr>
-              <a:t>      Action Center: CreateExternalTask ('Deal Desk' catalog)</a:t>
+              <a:t>    AWS Lambda HITL bridge mints token; suspend via UiPath.Persistence</a:t>
             </a:r>
           </a:p>
           <a:p>
@@ -17406,7 +17379,7 @@
               <a:rPr sz="1000" b="0">
                 <a:latin typeface="Segoe UI"/>
               </a:rPr>
-              <a:t>      Outlook: Adaptive Card with Approve / Reject / Request Info buttons</a:t>
+              <a:t>    Approver decides on any channel -&gt; robot resumes -&gt; process_response</a:t>
             </a:r>
           </a:p>
           <a:p>
@@ -17415,34 +17388,7 @@
               <a:rPr sz="1000" b="0">
                 <a:latin typeface="Segoe UI"/>
               </a:rPr>
-              <a:t>      Slack: Block Kit DM to approver</a:t>
-            </a:r>
-          </a:p>
-          <a:p>
-            <a:pPr algn="l"/>
-            <a:r>
-              <a:rPr sz="1000" b="0">
-                <a:latin typeface="Segoe UI"/>
-              </a:rPr>
-              <a:t>      Suspends via UiPath.Persistence.Activities (no BPMN polling)</a:t>
-            </a:r>
-          </a:p>
-          <a:p>
-            <a:pPr algn="l"/>
-            <a:r>
-              <a:rPr sz="1000" b="0">
-                <a:latin typeface="Segoe UI"/>
-              </a:rPr>
-              <a:t>    Approver decides via Adaptive Card OR Action Center -&gt; robot resumes</a:t>
-            </a:r>
-          </a:p>
-          <a:p>
-            <a:pPr algn="l"/>
-            <a:r>
-              <a:rPr sz="1000" b="0">
-                <a:latin typeface="Segoe UI"/>
-              </a:rPr>
-              <a:t>    Rejection short-circuits chain (BPMN completionCondition)</a:t>
+              <a:t>    Rejection short-circuits (BPMN completionCondition)</a:t>
             </a:r>
           </a:p>
           <a:p>
@@ -17459,30 +17405,6 @@
           </a:p>
         </p:txBody>
       </p:sp>
-      <p:pic>
-        <p:nvPicPr>
-          <p:cNvPr id="6" name="Picture 5" descr="deal-desk-code-graph.png"/>
-          <p:cNvPicPr>
-            <a:picLocks noChangeAspect="1"/>
-          </p:cNvPicPr>
-          <p:nvPr/>
-        </p:nvPicPr>
-        <p:blipFill>
-          <a:blip r:embed="rId2"/>
-          <a:stretch>
-            <a:fillRect/>
-          </a:stretch>
-        </p:blipFill>
-        <p:spPr>
-          <a:xfrm>
-            <a:off x="868680" y="3657600"/>
-            <a:ext cx="10424160" cy="2377440"/>
-          </a:xfrm>
-          <a:prstGeom prst="rect">
-            <a:avLst/>
-          </a:prstGeom>
-        </p:spPr>
-      </p:pic>
     </p:spTree>
     <p:extLst>
       <p:ext uri="{BB962C8B-B14F-4D97-AF65-F5344CB8AC3E}">
@@ -18280,7 +18202,7 @@
               <a:rPr sz="1200" b="0">
                 <a:latin typeface="Segoe UI"/>
               </a:rPr>
-              <a:t>Live test results — v1.3.12, Jun 22 2026 (all channels verified):</a:t>
+              <a:t>Live test results - Jun 22 2026 (all channels verified):</a:t>
             </a:r>
           </a:p>
           <a:p>
@@ -18289,7 +18211,7 @@
               <a:rPr sz="1200" b="0">
                 <a:latin typeface="Segoe UI"/>
               </a:rPr>
-              <a:t>  TEST-001: GlobalTech $120k/18% -&gt; Agent: Approve (within policy)</a:t>
+              <a:t>  TEST-001: GlobalTech $120k/18% -&gt; Approve (within policy)</a:t>
             </a:r>
           </a:p>
           <a:p>
@@ -18298,7 +18220,7 @@
               <a:rPr sz="1200" b="0">
                 <a:latin typeface="Segoe UI"/>
               </a:rPr>
-              <a:t>  TEST-002: MegaCorp $350k/32%   -&gt; Agent: Approve with conditions (escalation)</a:t>
+              <a:t>  TEST-002: MegaCorp $350k/32%  -&gt; Approve with conditions (escalation)</a:t>
             </a:r>
           </a:p>
           <a:p>
@@ -18307,7 +18229,7 @@
               <a:rPr sz="1200" b="0">
                 <a:latin typeface="Segoe UI"/>
               </a:rPr>
-              <a:t>  TEST-003: StartupXYZ $28k/45%  -&gt; Agent: Reject (margin impact too high)</a:t>
+              <a:t>  TEST-003: StartupXYZ $28k/45% -&gt; Reject (margin impact too high)</a:t>
             </a:r>
           </a:p>
           <a:p>
@@ -18316,7 +18238,7 @@
               <a:rPr sz="1200" b="0">
                 <a:latin typeface="Segoe UI"/>
               </a:rPr>
-              <a:t>  TEST-004: Pharma $780k/22%     -&gt; Agent: Approve (enterprise, Finance pre-approved)</a:t>
+              <a:t>  TEST-004: Pharma $780k/22%    -&gt; Approve (enterprise, Finance pre-approved)</a:t>
             </a:r>
           </a:p>
           <a:p>
@@ -18325,7 +18247,7 @@
               <a:rPr sz="1200" b="0">
                 <a:latin typeface="Segoe UI"/>
               </a:rPr>
-              <a:t>  Outlook Adaptive Card RECEIVED  |  Slack DM RECEIVED  |  Action Center WORKING</a:t>
+              <a:t>  Outlook Adaptive Card | Slack DM | Action Center  - all verified</a:t>
             </a:r>
           </a:p>
           <a:p>
@@ -18337,7 +18259,7 @@
               <a:rPr sz="1200" b="0">
                 <a:latin typeface="Segoe UI"/>
               </a:rPr>
-              <a:t>Scenario 1 — Auto-approve  (4% / $30k)</a:t>
+              <a:t>Scenario 1 - Auto-approve (4% / $30k): zero human touches.</a:t>
             </a:r>
           </a:p>
           <a:p>
@@ -18346,11 +18268,8 @@
               <a:rPr sz="1200" b="0">
                 <a:latin typeface="Segoe UI"/>
               </a:rPr>
-              <a:t>  Disposition: auto_approve. AE notified instantly. Zero human touches.</a:t>
-            </a:r>
-          </a:p>
-          <a:p>
-            <a:pPr algn="l"/>
+              <a:t>Scenario 2 - One approver (8% / $40k): Adaptive Card + Slack to Manager.</a:t>
+            </a:r>
           </a:p>
           <a:p>
             <a:pPr algn="l"/>
@@ -18358,7 +18277,7 @@
               <a:rPr sz="1200" b="0">
                 <a:latin typeface="Segoe UI"/>
               </a:rPr>
-              <a:t>Scenario 2 — One approver  (8% / $40k)</a:t>
+              <a:t>Scenario 3 - Full chain (30% / $1.2M): four sequential approvers; rejection</a:t>
             </a:r>
           </a:p>
           <a:p>
@@ -18367,46 +18286,7 @@
               <a:rPr sz="1200" b="0">
                 <a:latin typeface="Segoe UI"/>
               </a:rPr>
-              <a:t>  Robot sends Adaptive Card + Slack to Maya Stone (Manager).</a:t>
-            </a:r>
-          </a:p>
-          <a:p>
-            <a:pPr algn="l"/>
-            <a:r>
-              <a:rPr sz="1200" b="0">
-                <a:latin typeface="Segoe UI"/>
-              </a:rPr>
-              <a:t>  Maya approves via Outlook card. AE gets Slack DM + Outlook summary.</a:t>
-            </a:r>
-          </a:p>
-          <a:p>
-            <a:pPr algn="l"/>
-          </a:p>
-          <a:p>
-            <a:pPr algn="l"/>
-            <a:r>
-              <a:rPr sz="1200" b="0">
-                <a:latin typeface="Segoe UI"/>
-              </a:rPr>
-              <a:t>Scenario 3 — Full chain  (30% / $1.2M)</a:t>
-            </a:r>
-          </a:p>
-          <a:p>
-            <a:pPr algn="l"/>
-            <a:r>
-              <a:rPr sz="1200" b="0">
-                <a:latin typeface="Segoe UI"/>
-              </a:rPr>
-              <a:t>  Four sequential approvers. Each gets Adaptive Card + Slack.</a:t>
-            </a:r>
-          </a:p>
-          <a:p>
-            <a:pPr algn="l"/>
-            <a:r>
-              <a:rPr sz="1200" b="0">
-                <a:latin typeface="Segoe UI"/>
-              </a:rPr>
-              <a:t>  Rejection at any step short-circuits. Full Data Fabric audit trail.</a:t>
+              <a:t>  short-circuits; full Data Fabric audit trail.</a:t>
             </a:r>
           </a:p>
         </p:txBody>

</xml_diff>

<commit_message>
Fix deck slides (visible text, real data, diagram); harden presentation skill
Co-authored-by: Cursor <cursoragent@cursor.com>
</commit_message>
<xml_diff>
--- a/submission/deck/Submission-Template-Deal-Desk-Agent.pptx
+++ b/submission/deck/Submission-Template-Deal-Desk-Agent.pptx
@@ -11932,53 +11932,6 @@
           <a:chExt cx="0" cy="0"/>
         </a:xfrm>
       </p:grpSpPr>
-      <p:pic>
-        <p:nvPicPr>
-          <p:cNvPr id="1026" name="Picture 2">
-            <a:extLst>
-              <a:ext uri="{FF2B5EF4-FFF2-40B4-BE49-F238E27FC236}">
-                <a16:creationId xmlns:a16="http://schemas.microsoft.com/office/drawing/2014/main" id="{E66991E2-8AE2-DD26-A9A4-214B73B61F71}"/>
-              </a:ext>
-            </a:extLst>
-          </p:cNvPr>
-          <p:cNvPicPr>
-            <a:picLocks noChangeAspect="1" noChangeArrowheads="1"/>
-          </p:cNvPicPr>
-          <p:nvPr/>
-        </p:nvPicPr>
-        <p:blipFill>
-          <a:blip r:embed="rId2">
-            <a:extLst>
-              <a:ext uri="{28A0092B-C50C-407E-A947-70E740481C1C}">
-                <a14:useLocalDpi xmlns:a14="http://schemas.microsoft.com/office/drawing/2010/main" val="0"/>
-              </a:ext>
-            </a:extLst>
-          </a:blip>
-          <a:srcRect/>
-          <a:stretch>
-            <a:fillRect/>
-          </a:stretch>
-        </p:blipFill>
-        <p:spPr bwMode="auto">
-          <a:xfrm>
-            <a:off x="586255" y="1925979"/>
-            <a:ext cx="2223500" cy="2228624"/>
-          </a:xfrm>
-          <a:prstGeom prst="rect">
-            <a:avLst/>
-          </a:prstGeom>
-          <a:noFill/>
-          <a:extLst>
-            <a:ext uri="{909E8E84-426E-40DD-AFC4-6F175D3DCCD1}">
-              <a14:hiddenFill xmlns:a14="http://schemas.microsoft.com/office/drawing/2010/main">
-                <a:solidFill>
-                  <a:srgbClr val="FFFFFF"/>
-                </a:solidFill>
-              </a14:hiddenFill>
-            </a:ext>
-          </a:extLst>
-        </p:spPr>
-      </p:pic>
       <p:sp>
         <p:nvSpPr>
           <p:cNvPr id="3" name="Text Placeholder 6">
@@ -11995,7 +11948,7 @@
         </p:nvSpPr>
         <p:spPr>
           <a:xfrm>
-            <a:off x="308294" y="4436925"/>
+            <a:off x="308294" y="2834640"/>
             <a:ext cx="2710314" cy="489737"/>
           </a:xfrm>
           <a:prstGeom prst="rect">
@@ -12003,7 +11956,7 @@
           </a:prstGeom>
         </p:spPr>
         <p:txBody>
-          <a:bodyPr vert="horz" lIns="0" tIns="0" rIns="0" bIns="0" rtlCol="0" anchor="b" anchorCtr="1">
+          <a:bodyPr vert="horz" lIns="0" tIns="0" rIns="0" bIns="0" rtlCol="0" anchor="b" anchorCtr="1" wrap="square">
             <a:noAutofit/>
           </a:bodyPr>
           <a:lstStyle>
@@ -12161,7 +12114,10 @@
           <a:p>
             <a:pPr algn="l"/>
             <a:r>
-              <a:rPr sz="1800" b="1">
+              <a:rPr sz="1500" b="1">
+                <a:solidFill>
+                  <a:srgbClr val="0F172A"/>
+                </a:solidFill>
                 <a:latin typeface="Segoe UI"/>
               </a:rPr>
               <a:t>Daniela Rosenstein</a:t>
@@ -12185,15 +12141,15 @@
         </p:nvSpPr>
         <p:spPr>
           <a:xfrm>
-            <a:off x="342659" y="5063729"/>
-            <a:ext cx="2710691" cy="1141008"/>
+            <a:off x="342659" y="3474720"/>
+            <a:ext cx="2710691" cy="1005840"/>
           </a:xfrm>
           <a:prstGeom prst="rect">
             <a:avLst/>
           </a:prstGeom>
         </p:spPr>
         <p:txBody>
-          <a:bodyPr vert="horz" lIns="0" tIns="0" rIns="0" bIns="0" rtlCol="0" anchor="t" anchorCtr="1">
+          <a:bodyPr vert="horz" lIns="0" tIns="0" rIns="0" bIns="0" rtlCol="0" anchor="t" anchorCtr="1" wrap="square">
             <a:noAutofit/>
           </a:bodyPr>
           <a:lstStyle>
@@ -12348,7 +12304,10 @@
           <a:p>
             <a:pPr algn="l"/>
             <a:r>
-              <a:rPr sz="1300" b="0">
+              <a:rPr sz="1100" b="0">
+                <a:solidFill>
+                  <a:srgbClr val="475569"/>
+                </a:solidFill>
                 <a:latin typeface="Segoe UI"/>
               </a:rPr>
               <a:t>Builder @ Cato Networks</a:t>
@@ -12356,53 +12315,6 @@
           </a:p>
         </p:txBody>
       </p:sp>
-      <p:pic>
-        <p:nvPicPr>
-          <p:cNvPr id="5" name="Picture 2">
-            <a:extLst>
-              <a:ext uri="{FF2B5EF4-FFF2-40B4-BE49-F238E27FC236}">
-                <a16:creationId xmlns:a16="http://schemas.microsoft.com/office/drawing/2014/main" id="{8D8FDD73-F412-713B-3DD2-71DA1C30C400}"/>
-              </a:ext>
-            </a:extLst>
-          </p:cNvPr>
-          <p:cNvPicPr>
-            <a:picLocks noChangeAspect="1" noChangeArrowheads="1"/>
-          </p:cNvPicPr>
-          <p:nvPr/>
-        </p:nvPicPr>
-        <p:blipFill>
-          <a:blip r:embed="rId2">
-            <a:extLst>
-              <a:ext uri="{28A0092B-C50C-407E-A947-70E740481C1C}">
-                <a14:useLocalDpi xmlns:a14="http://schemas.microsoft.com/office/drawing/2010/main" val="0"/>
-              </a:ext>
-            </a:extLst>
-          </a:blip>
-          <a:srcRect/>
-          <a:stretch>
-            <a:fillRect/>
-          </a:stretch>
-        </p:blipFill>
-        <p:spPr bwMode="auto">
-          <a:xfrm>
-            <a:off x="3378334" y="1925979"/>
-            <a:ext cx="2223500" cy="2228624"/>
-          </a:xfrm>
-          <a:prstGeom prst="rect">
-            <a:avLst/>
-          </a:prstGeom>
-          <a:noFill/>
-          <a:extLst>
-            <a:ext uri="{909E8E84-426E-40DD-AFC4-6F175D3DCCD1}">
-              <a14:hiddenFill xmlns:a14="http://schemas.microsoft.com/office/drawing/2010/main">
-                <a:solidFill>
-                  <a:srgbClr val="FFFFFF"/>
-                </a:solidFill>
-              </a14:hiddenFill>
-            </a:ext>
-          </a:extLst>
-        </p:spPr>
-      </p:pic>
       <p:sp>
         <p:nvSpPr>
           <p:cNvPr id="6" name="Text Placeholder 6">
@@ -12419,7 +12331,7 @@
         </p:nvSpPr>
         <p:spPr>
           <a:xfrm>
-            <a:off x="3216503" y="4450509"/>
+            <a:off x="3216503" y="2834640"/>
             <a:ext cx="2710314" cy="489737"/>
           </a:xfrm>
           <a:prstGeom prst="rect">
@@ -12427,7 +12339,7 @@
           </a:prstGeom>
         </p:spPr>
         <p:txBody>
-          <a:bodyPr vert="horz" lIns="0" tIns="0" rIns="0" bIns="0" rtlCol="0" anchor="b" anchorCtr="1">
+          <a:bodyPr vert="horz" lIns="0" tIns="0" rIns="0" bIns="0" rtlCol="0" anchor="b" anchorCtr="1" wrap="square">
             <a:noAutofit/>
           </a:bodyPr>
           <a:lstStyle>
@@ -12585,7 +12497,10 @@
           <a:p>
             <a:pPr algn="l"/>
             <a:r>
-              <a:rPr sz="1800" b="1">
+              <a:rPr sz="1500" b="1">
+                <a:solidFill>
+                  <a:srgbClr val="0F172A"/>
+                </a:solidFill>
                 <a:latin typeface="Segoe UI"/>
               </a:rPr>
               <a:t>Coded Agents (LangGraph)</a:t>
@@ -12609,15 +12524,15 @@
         </p:nvSpPr>
         <p:spPr>
           <a:xfrm>
-            <a:off x="3105672" y="5062793"/>
-            <a:ext cx="2710691" cy="1141008"/>
+            <a:off x="3105672" y="3474720"/>
+            <a:ext cx="2710691" cy="1005840"/>
           </a:xfrm>
           <a:prstGeom prst="rect">
             <a:avLst/>
           </a:prstGeom>
         </p:spPr>
         <p:txBody>
-          <a:bodyPr vert="horz" lIns="0" tIns="0" rIns="0" bIns="0" rtlCol="0" anchor="t" anchorCtr="1">
+          <a:bodyPr vert="horz" lIns="0" tIns="0" rIns="0" bIns="0" rtlCol="0" anchor="t" anchorCtr="1" wrap="square">
             <a:noAutofit/>
           </a:bodyPr>
           <a:lstStyle>
@@ -12772,61 +12687,17 @@
           <a:p>
             <a:pPr algn="l"/>
             <a:r>
-              <a:rPr sz="1300" b="0">
+              <a:rPr sz="1100" b="0">
+                <a:solidFill>
+                  <a:srgbClr val="475569"/>
+                </a:solidFill>
                 <a:latin typeface="Segoe UI"/>
               </a:rPr>
-              <a:t>plan / render / process_response (Python)</a:t>
+              <a:t>plan / render / process_response</a:t>
             </a:r>
           </a:p>
         </p:txBody>
       </p:sp>
-      <p:pic>
-        <p:nvPicPr>
-          <p:cNvPr id="8" name="Picture 2">
-            <a:extLst>
-              <a:ext uri="{FF2B5EF4-FFF2-40B4-BE49-F238E27FC236}">
-                <a16:creationId xmlns:a16="http://schemas.microsoft.com/office/drawing/2014/main" id="{7DBA6F5D-90AD-506A-CE4D-89319B51CB6E}"/>
-              </a:ext>
-            </a:extLst>
-          </p:cNvPr>
-          <p:cNvPicPr>
-            <a:picLocks noChangeAspect="1" noChangeArrowheads="1"/>
-          </p:cNvPicPr>
-          <p:nvPr/>
-        </p:nvPicPr>
-        <p:blipFill>
-          <a:blip r:embed="rId2">
-            <a:extLst>
-              <a:ext uri="{28A0092B-C50C-407E-A947-70E740481C1C}">
-                <a14:useLocalDpi xmlns:a14="http://schemas.microsoft.com/office/drawing/2010/main" val="0"/>
-              </a:ext>
-            </a:extLst>
-          </a:blip>
-          <a:srcRect/>
-          <a:stretch>
-            <a:fillRect/>
-          </a:stretch>
-        </p:blipFill>
-        <p:spPr bwMode="auto">
-          <a:xfrm>
-            <a:off x="6251716" y="1973262"/>
-            <a:ext cx="2223500" cy="2228624"/>
-          </a:xfrm>
-          <a:prstGeom prst="rect">
-            <a:avLst/>
-          </a:prstGeom>
-          <a:noFill/>
-          <a:extLst>
-            <a:ext uri="{909E8E84-426E-40DD-AFC4-6F175D3DCCD1}">
-              <a14:hiddenFill xmlns:a14="http://schemas.microsoft.com/office/drawing/2010/main">
-                <a:solidFill>
-                  <a:srgbClr val="FFFFFF"/>
-                </a:solidFill>
-              </a14:hiddenFill>
-            </a:ext>
-          </a:extLst>
-        </p:spPr>
-      </p:pic>
       <p:sp>
         <p:nvSpPr>
           <p:cNvPr id="9" name="Text Placeholder 6">
@@ -12843,7 +12714,7 @@
         </p:nvSpPr>
         <p:spPr>
           <a:xfrm>
-            <a:off x="6148101" y="4450509"/>
+            <a:off x="6148101" y="2834640"/>
             <a:ext cx="2710314" cy="489737"/>
           </a:xfrm>
           <a:prstGeom prst="rect">
@@ -12851,7 +12722,7 @@
           </a:prstGeom>
         </p:spPr>
         <p:txBody>
-          <a:bodyPr vert="horz" lIns="0" tIns="0" rIns="0" bIns="0" rtlCol="0" anchor="b" anchorCtr="1">
+          <a:bodyPr vert="horz" lIns="0" tIns="0" rIns="0" bIns="0" rtlCol="0" anchor="b" anchorCtr="1" wrap="square">
             <a:noAutofit/>
           </a:bodyPr>
           <a:lstStyle>
@@ -13009,7 +12880,10 @@
           <a:p>
             <a:pPr algn="l"/>
             <a:r>
-              <a:rPr sz="1800" b="1">
+              <a:rPr sz="1500" b="1">
+                <a:solidFill>
+                  <a:srgbClr val="0F172A"/>
+                </a:solidFill>
                 <a:latin typeface="Segoe UI"/>
               </a:rPr>
               <a:t>Maestro BPMN</a:t>
@@ -13033,15 +12907,15 @@
         </p:nvSpPr>
         <p:spPr>
           <a:xfrm>
-            <a:off x="6148101" y="5060108"/>
-            <a:ext cx="2710691" cy="1141008"/>
+            <a:off x="6148101" y="3474720"/>
+            <a:ext cx="2710691" cy="1005840"/>
           </a:xfrm>
           <a:prstGeom prst="rect">
             <a:avLst/>
           </a:prstGeom>
         </p:spPr>
         <p:txBody>
-          <a:bodyPr vert="horz" lIns="0" tIns="0" rIns="0" bIns="0" rtlCol="0" anchor="t" anchorCtr="1">
+          <a:bodyPr vert="horz" lIns="0" tIns="0" rIns="0" bIns="0" rtlCol="0" anchor="t" anchorCtr="1" wrap="square">
             <a:noAutofit/>
           </a:bodyPr>
           <a:lstStyle>
@@ -13196,61 +13070,17 @@
           <a:p>
             <a:pPr algn="l"/>
             <a:r>
-              <a:rPr sz="1300" b="0">
+              <a:rPr sz="1100" b="0">
+                <a:solidFill>
+                  <a:srgbClr val="475569"/>
+                </a:solidFill>
                 <a:latin typeface="Segoe UI"/>
               </a:rPr>
-              <a:t>orchestration, gateway, sequential loop</a:t>
+              <a:t>orchestration + sequential approval loop</a:t>
             </a:r>
           </a:p>
         </p:txBody>
       </p:sp>
-      <p:pic>
-        <p:nvPicPr>
-          <p:cNvPr id="11" name="Picture 2">
-            <a:extLst>
-              <a:ext uri="{FF2B5EF4-FFF2-40B4-BE49-F238E27FC236}">
-                <a16:creationId xmlns:a16="http://schemas.microsoft.com/office/drawing/2014/main" id="{49E04C0B-2472-ED45-82CC-742C963F71A2}"/>
-              </a:ext>
-            </a:extLst>
-          </p:cNvPr>
-          <p:cNvPicPr>
-            <a:picLocks noChangeAspect="1" noChangeArrowheads="1"/>
-          </p:cNvPicPr>
-          <p:nvPr/>
-        </p:nvPicPr>
-        <p:blipFill>
-          <a:blip r:embed="rId2">
-            <a:extLst>
-              <a:ext uri="{28A0092B-C50C-407E-A947-70E740481C1C}">
-                <a14:useLocalDpi xmlns:a14="http://schemas.microsoft.com/office/drawing/2010/main" val="0"/>
-              </a:ext>
-            </a:extLst>
-          </a:blip>
-          <a:srcRect/>
-          <a:stretch>
-            <a:fillRect/>
-          </a:stretch>
-        </p:blipFill>
-        <p:spPr bwMode="auto">
-          <a:xfrm>
-            <a:off x="9125098" y="1973262"/>
-            <a:ext cx="2223500" cy="2228624"/>
-          </a:xfrm>
-          <a:prstGeom prst="rect">
-            <a:avLst/>
-          </a:prstGeom>
-          <a:noFill/>
-          <a:extLst>
-            <a:ext uri="{909E8E84-426E-40DD-AFC4-6F175D3DCCD1}">
-              <a14:hiddenFill xmlns:a14="http://schemas.microsoft.com/office/drawing/2010/main">
-                <a:solidFill>
-                  <a:srgbClr val="FFFFFF"/>
-                </a:solidFill>
-              </a14:hiddenFill>
-            </a:ext>
-          </a:extLst>
-        </p:spPr>
-      </p:pic>
       <p:sp>
         <p:nvSpPr>
           <p:cNvPr id="12" name="Text Placeholder 6">
@@ -13267,7 +13097,7 @@
         </p:nvSpPr>
         <p:spPr>
           <a:xfrm>
-            <a:off x="8858415" y="4436925"/>
+            <a:off x="8858415" y="2834640"/>
             <a:ext cx="2710314" cy="489737"/>
           </a:xfrm>
           <a:prstGeom prst="rect">
@@ -13275,7 +13105,7 @@
           </a:prstGeom>
         </p:spPr>
         <p:txBody>
-          <a:bodyPr vert="horz" lIns="0" tIns="0" rIns="0" bIns="0" rtlCol="0" anchor="b" anchorCtr="1">
+          <a:bodyPr vert="horz" lIns="0" tIns="0" rIns="0" bIns="0" rtlCol="0" anchor="b" anchorCtr="1" wrap="square">
             <a:noAutofit/>
           </a:bodyPr>
           <a:lstStyle>
@@ -13433,7 +13263,10 @@
           <a:p>
             <a:pPr algn="l"/>
             <a:r>
-              <a:rPr sz="1800" b="1">
+              <a:rPr sz="1500" b="1">
+                <a:solidFill>
+                  <a:srgbClr val="0F172A"/>
+                </a:solidFill>
                 <a:latin typeface="Segoe UI"/>
               </a:rPr>
               <a:t>WaitDecision Robot</a:t>
@@ -13457,15 +13290,15 @@
         </p:nvSpPr>
         <p:spPr>
           <a:xfrm>
-            <a:off x="8881502" y="5060108"/>
-            <a:ext cx="2710691" cy="1141008"/>
+            <a:off x="8881502" y="3474720"/>
+            <a:ext cx="2710691" cy="1005840"/>
           </a:xfrm>
           <a:prstGeom prst="rect">
             <a:avLst/>
           </a:prstGeom>
         </p:spPr>
         <p:txBody>
-          <a:bodyPr vert="horz" lIns="0" tIns="0" rIns="0" bIns="0" rtlCol="0" anchor="t" anchorCtr="1">
+          <a:bodyPr vert="horz" lIns="0" tIns="0" rIns="0" bIns="0" rtlCol="0" anchor="t" anchorCtr="1" wrap="square">
             <a:noAutofit/>
           </a:bodyPr>
           <a:lstStyle>
@@ -13620,10 +13453,13 @@
           <a:p>
             <a:pPr algn="l"/>
             <a:r>
-              <a:rPr sz="1300" b="0">
+              <a:rPr sz="1100" b="0">
+                <a:solidFill>
+                  <a:srgbClr val="475569"/>
+                </a:solidFill>
                 <a:latin typeface="Segoe UI"/>
               </a:rPr>
-              <a:t>RPA: 3 channels + UiPath.Persistence wait</a:t>
+              <a:t>RPA: 3 channels + Persistence wait</a:t>
             </a:r>
           </a:p>
         </p:txBody>
@@ -14663,38 +14499,15 @@
                     <a:bodyPr/>
                     <a:lstStyle/>
                     <a:p>
-                      <a:pPr algn="l" fontAlgn="base">
-                        <a:lnSpc>
-                          <a:spcPts val="1425"/>
-                        </a:lnSpc>
-                        <a:buNone/>
-                      </a:pPr>
                       <a:r>
-                        <a:rPr lang="en-US" sz="1800" b="1" i="0" u="none" strike="noStrike" dirty="0">
+                        <a:rPr b="1" sz="1300">
                           <a:solidFill>
                             <a:srgbClr val="FFFFFF"/>
                           </a:solidFill>
-                          <a:effectLst/>
-                          <a:latin typeface="Arial" panose="020B0604020202020204" pitchFamily="34" charset="0"/>
+                          <a:latin typeface="Segoe UI"/>
                         </a:rPr>
-                        <a:t>End-user</a:t>
+                        <a:t>End users</a:t>
                       </a:r>
-                      <a:r>
-                        <a:rPr lang="en-US" sz="1800" b="1" i="0" dirty="0">
-                          <a:solidFill>
-                            <a:srgbClr val="FFFFFF"/>
-                          </a:solidFill>
-                          <a:effectLst/>
-                          <a:latin typeface="Arial" panose="020B0604020202020204" pitchFamily="34" charset="0"/>
-                        </a:rPr>
-                        <a:t>​</a:t>
-                      </a:r>
-                      <a:endParaRPr lang="en-US" sz="1800" b="1" i="0" dirty="0">
-                        <a:solidFill>
-                          <a:srgbClr val="FFFFFF"/>
-                        </a:solidFill>
-                        <a:effectLst/>
-                      </a:endParaRPr>
                     </a:p>
                   </a:txBody>
                   <a:tcPr anchor="ctr">
@@ -14744,38 +14557,15 @@
                     <a:bodyPr/>
                     <a:lstStyle/>
                     <a:p>
-                      <a:pPr algn="l" fontAlgn="base">
-                        <a:lnSpc>
-                          <a:spcPts val="1425"/>
-                        </a:lnSpc>
-                        <a:buNone/>
-                      </a:pPr>
                       <a:r>
-                        <a:rPr lang="en-US" sz="1800" b="0" i="0" u="none" strike="noStrike" dirty="0">
+                        <a:rPr sz="1100">
                           <a:solidFill>
-                            <a:srgbClr val="000000"/>
+                            <a:srgbClr val="0F172A"/>
                           </a:solidFill>
-                          <a:effectLst/>
-                          <a:latin typeface="Arial" panose="020B0604020202020204" pitchFamily="34" charset="0"/>
+                          <a:latin typeface="Segoe UI"/>
                         </a:rPr>
-                        <a:t>Lorem Ipsum</a:t>
+                        <a:t>Renewals analysts, AEs, deal-desk approvers</a:t>
                       </a:r>
-                      <a:r>
-                        <a:rPr lang="en-US" sz="1800" b="1" i="0" dirty="0">
-                          <a:solidFill>
-                            <a:srgbClr val="FFFFFF"/>
-                          </a:solidFill>
-                          <a:effectLst/>
-                          <a:latin typeface="Arial" panose="020B0604020202020204" pitchFamily="34" charset="0"/>
-                        </a:rPr>
-                        <a:t>​</a:t>
-                      </a:r>
-                      <a:endParaRPr lang="en-US" sz="1800" b="1" i="0" dirty="0">
-                        <a:solidFill>
-                          <a:srgbClr val="FFFFFF"/>
-                        </a:solidFill>
-                        <a:effectLst/>
-                      </a:endParaRPr>
                     </a:p>
                   </a:txBody>
                   <a:tcPr anchor="ctr">
@@ -14832,38 +14622,15 @@
                     <a:bodyPr/>
                     <a:lstStyle/>
                     <a:p>
-                      <a:pPr algn="l" fontAlgn="base">
-                        <a:lnSpc>
-                          <a:spcPts val="1425"/>
-                        </a:lnSpc>
-                        <a:buNone/>
-                      </a:pPr>
                       <a:r>
-                        <a:rPr lang="en-US" sz="1800" b="1" i="0" u="none" strike="noStrike" dirty="0">
+                        <a:rPr b="1" sz="1300">
                           <a:solidFill>
                             <a:srgbClr val="FFFFFF"/>
                           </a:solidFill>
-                          <a:effectLst/>
-                          <a:latin typeface="Arial" panose="020B0604020202020204" pitchFamily="34" charset="0"/>
+                          <a:latin typeface="Segoe UI"/>
                         </a:rPr>
-                        <a:t>User department</a:t>
+                        <a:t>Department</a:t>
                       </a:r>
-                      <a:r>
-                        <a:rPr lang="en-US" sz="1800" b="0" i="0" dirty="0">
-                          <a:solidFill>
-                            <a:srgbClr val="000000"/>
-                          </a:solidFill>
-                          <a:effectLst/>
-                          <a:latin typeface="Arial" panose="020B0604020202020204" pitchFamily="34" charset="0"/>
-                        </a:rPr>
-                        <a:t>​</a:t>
-                      </a:r>
-                      <a:endParaRPr lang="en-US" sz="1800" b="0" i="0" dirty="0">
-                        <a:solidFill>
-                          <a:srgbClr val="000000"/>
-                        </a:solidFill>
-                        <a:effectLst/>
-                      </a:endParaRPr>
                     </a:p>
                   </a:txBody>
                   <a:tcPr anchor="ctr">
@@ -14913,38 +14680,15 @@
                     <a:bodyPr/>
                     <a:lstStyle/>
                     <a:p>
-                      <a:pPr algn="l" fontAlgn="base">
-                        <a:lnSpc>
-                          <a:spcPts val="1425"/>
-                        </a:lnSpc>
-                        <a:buNone/>
-                      </a:pPr>
                       <a:r>
-                        <a:rPr lang="en-US" sz="1800" b="0" i="0" u="none" strike="noStrike" dirty="0">
+                        <a:rPr sz="1100">
                           <a:solidFill>
-                            <a:srgbClr val="000000"/>
+                            <a:srgbClr val="0F172A"/>
                           </a:solidFill>
-                          <a:effectLst/>
-                          <a:latin typeface="Arial" panose="020B0604020202020204" pitchFamily="34" charset="0"/>
+                          <a:latin typeface="Segoe UI"/>
                         </a:rPr>
-                        <a:t>Lorem Ipsum</a:t>
+                        <a:t>Sales / Revenue Operations + Finance</a:t>
                       </a:r>
-                      <a:r>
-                        <a:rPr lang="en-US" sz="1800" b="0" i="0" dirty="0">
-                          <a:solidFill>
-                            <a:srgbClr val="000000"/>
-                          </a:solidFill>
-                          <a:effectLst/>
-                          <a:latin typeface="Arial" panose="020B0604020202020204" pitchFamily="34" charset="0"/>
-                        </a:rPr>
-                        <a:t>​</a:t>
-                      </a:r>
-                      <a:endParaRPr lang="en-US" sz="1800" b="0" i="0" dirty="0">
-                        <a:solidFill>
-                          <a:srgbClr val="000000"/>
-                        </a:solidFill>
-                        <a:effectLst/>
-                      </a:endParaRPr>
                     </a:p>
                   </a:txBody>
                   <a:tcPr anchor="ctr">
@@ -15001,38 +14745,15 @@
                     <a:bodyPr/>
                     <a:lstStyle/>
                     <a:p>
-                      <a:pPr algn="l" fontAlgn="base">
-                        <a:lnSpc>
-                          <a:spcPts val="1425"/>
-                        </a:lnSpc>
-                        <a:buNone/>
-                      </a:pPr>
                       <a:r>
-                        <a:rPr lang="en-US" sz="1800" b="1" i="0" u="none" strike="noStrike">
+                        <a:rPr b="1" sz="1300">
                           <a:solidFill>
                             <a:srgbClr val="FFFFFF"/>
                           </a:solidFill>
-                          <a:effectLst/>
-                          <a:latin typeface="Arial" panose="020B0604020202020204" pitchFamily="34" charset="0"/>
+                          <a:latin typeface="Segoe UI"/>
                         </a:rPr>
                         <a:t>Industries</a:t>
                       </a:r>
-                      <a:r>
-                        <a:rPr lang="en-US" sz="1800" b="0" i="0">
-                          <a:solidFill>
-                            <a:srgbClr val="000000"/>
-                          </a:solidFill>
-                          <a:effectLst/>
-                          <a:latin typeface="Arial" panose="020B0604020202020204" pitchFamily="34" charset="0"/>
-                        </a:rPr>
-                        <a:t>​</a:t>
-                      </a:r>
-                      <a:endParaRPr lang="en-US" sz="1800" b="0" i="0">
-                        <a:solidFill>
-                          <a:srgbClr val="000000"/>
-                        </a:solidFill>
-                        <a:effectLst/>
-                      </a:endParaRPr>
                     </a:p>
                   </a:txBody>
                   <a:tcPr anchor="ctr">
@@ -15082,38 +14803,15 @@
                     <a:bodyPr/>
                     <a:lstStyle/>
                     <a:p>
-                      <a:pPr algn="l" fontAlgn="base">
-                        <a:lnSpc>
-                          <a:spcPts val="1425"/>
-                        </a:lnSpc>
-                        <a:buNone/>
-                      </a:pPr>
                       <a:r>
-                        <a:rPr lang="en-US" sz="1800" b="0" i="0" u="none" strike="noStrike" dirty="0">
+                        <a:rPr sz="1100">
                           <a:solidFill>
-                            <a:srgbClr val="000000"/>
+                            <a:srgbClr val="0F172A"/>
                           </a:solidFill>
-                          <a:effectLst/>
-                          <a:latin typeface="Arial" panose="020B0604020202020204" pitchFamily="34" charset="0"/>
+                          <a:latin typeface="Segoe UI"/>
                         </a:rPr>
-                        <a:t>Lorem Ipsum</a:t>
+                        <a:t>Any B2B org with renewals &amp; pricing exceptions</a:t>
                       </a:r>
-                      <a:r>
-                        <a:rPr lang="en-US" sz="1800" b="0" i="0" dirty="0">
-                          <a:solidFill>
-                            <a:srgbClr val="000000"/>
-                          </a:solidFill>
-                          <a:effectLst/>
-                          <a:latin typeface="Arial" panose="020B0604020202020204" pitchFamily="34" charset="0"/>
-                        </a:rPr>
-                        <a:t>​</a:t>
-                      </a:r>
-                      <a:endParaRPr lang="en-US" sz="1800" b="0" i="0" dirty="0">
-                        <a:solidFill>
-                          <a:srgbClr val="000000"/>
-                        </a:solidFill>
-                        <a:effectLst/>
-                      </a:endParaRPr>
                     </a:p>
                   </a:txBody>
                   <a:tcPr anchor="ctr">
@@ -15170,38 +14868,15 @@
                     <a:bodyPr/>
                     <a:lstStyle/>
                     <a:p>
-                      <a:pPr algn="l" fontAlgn="base">
-                        <a:lnSpc>
-                          <a:spcPts val="1425"/>
-                        </a:lnSpc>
-                        <a:buNone/>
-                      </a:pPr>
                       <a:r>
-                        <a:rPr lang="en-US" sz="1800" b="1" i="0" u="none" strike="noStrike" dirty="0">
+                        <a:rPr b="1" sz="1300">
                           <a:solidFill>
                             <a:srgbClr val="FFFFFF"/>
                           </a:solidFill>
-                          <a:effectLst/>
-                          <a:latin typeface="Arial" panose="020B0604020202020204" pitchFamily="34" charset="0"/>
+                          <a:latin typeface="Segoe UI"/>
                         </a:rPr>
-                        <a:t>UiPath products used</a:t>
+                        <a:t>UiPath products</a:t>
                       </a:r>
-                      <a:r>
-                        <a:rPr lang="en-US" sz="1800" b="0" i="0" dirty="0">
-                          <a:solidFill>
-                            <a:srgbClr val="000000"/>
-                          </a:solidFill>
-                          <a:effectLst/>
-                          <a:latin typeface="Arial" panose="020B0604020202020204" pitchFamily="34" charset="0"/>
-                        </a:rPr>
-                        <a:t>​</a:t>
-                      </a:r>
-                      <a:endParaRPr lang="en-US" sz="1800" b="0" i="0" dirty="0">
-                        <a:solidFill>
-                          <a:srgbClr val="000000"/>
-                        </a:solidFill>
-                        <a:effectLst/>
-                      </a:endParaRPr>
                     </a:p>
                   </a:txBody>
                   <a:tcPr anchor="ctr">
@@ -15251,38 +14926,15 @@
                     <a:bodyPr/>
                     <a:lstStyle/>
                     <a:p>
-                      <a:pPr algn="l" fontAlgn="base">
-                        <a:lnSpc>
-                          <a:spcPts val="1425"/>
-                        </a:lnSpc>
-                        <a:buNone/>
-                      </a:pPr>
                       <a:r>
-                        <a:rPr lang="en-US" sz="1800" b="0" i="0" u="none" strike="noStrike">
+                        <a:rPr sz="1100">
                           <a:solidFill>
-                            <a:srgbClr val="000000"/>
+                            <a:srgbClr val="0F172A"/>
                           </a:solidFill>
-                          <a:effectLst/>
-                          <a:latin typeface="Arial" panose="020B0604020202020204" pitchFamily="34" charset="0"/>
+                          <a:latin typeface="Segoe UI"/>
                         </a:rPr>
-                        <a:t>Lorem Ipsum</a:t>
+                        <a:t>Maestro BPMN, Coded Agents, Action Center, Data Fabric, RPA, Integration Service, AgentHub MCP</a:t>
                       </a:r>
-                      <a:r>
-                        <a:rPr lang="en-US" sz="1800" b="0" i="0">
-                          <a:solidFill>
-                            <a:srgbClr val="000000"/>
-                          </a:solidFill>
-                          <a:effectLst/>
-                          <a:latin typeface="Arial" panose="020B0604020202020204" pitchFamily="34" charset="0"/>
-                        </a:rPr>
-                        <a:t>​</a:t>
-                      </a:r>
-                      <a:endParaRPr lang="en-US" sz="1800" b="0" i="0">
-                        <a:solidFill>
-                          <a:srgbClr val="000000"/>
-                        </a:solidFill>
-                        <a:effectLst/>
-                      </a:endParaRPr>
                     </a:p>
                   </a:txBody>
                   <a:tcPr anchor="ctr">
@@ -15339,38 +14991,15 @@
                     <a:bodyPr/>
                     <a:lstStyle/>
                     <a:p>
-                      <a:pPr algn="l" fontAlgn="base">
-                        <a:lnSpc>
-                          <a:spcPts val="1425"/>
-                        </a:lnSpc>
-                        <a:buNone/>
-                      </a:pPr>
                       <a:r>
-                        <a:rPr lang="en-US" sz="1800" b="1" i="0" u="none" strike="noStrike" dirty="0">
+                        <a:rPr b="1" sz="1300">
                           <a:solidFill>
                             <a:srgbClr val="FFFFFF"/>
                           </a:solidFill>
-                          <a:effectLst/>
-                          <a:latin typeface="Arial" panose="020B0604020202020204" pitchFamily="34" charset="0"/>
+                          <a:latin typeface="Segoe UI"/>
                         </a:rPr>
-                        <a:t>Other - integrations / APIs / technologies used</a:t>
+                        <a:t>Integrations / tech</a:t>
                       </a:r>
-                      <a:r>
-                        <a:rPr lang="en-US" sz="1800" b="0" i="0" dirty="0">
-                          <a:solidFill>
-                            <a:srgbClr val="000000"/>
-                          </a:solidFill>
-                          <a:effectLst/>
-                          <a:latin typeface="Arial" panose="020B0604020202020204" pitchFamily="34" charset="0"/>
-                        </a:rPr>
-                        <a:t>​</a:t>
-                      </a:r>
-                      <a:endParaRPr lang="en-US" sz="1800" b="0" i="0" dirty="0">
-                        <a:solidFill>
-                          <a:srgbClr val="000000"/>
-                        </a:solidFill>
-                        <a:effectLst/>
-                      </a:endParaRPr>
                     </a:p>
                   </a:txBody>
                   <a:tcPr anchor="ctr">
@@ -15420,38 +15049,15 @@
                     <a:bodyPr/>
                     <a:lstStyle/>
                     <a:p>
-                      <a:pPr algn="l" fontAlgn="base">
-                        <a:lnSpc>
-                          <a:spcPts val="1425"/>
-                        </a:lnSpc>
-                        <a:buNone/>
-                      </a:pPr>
                       <a:r>
-                        <a:rPr lang="en-US" sz="1800" b="0" i="0" u="none" strike="noStrike" dirty="0">
+                        <a:rPr sz="1100">
                           <a:solidFill>
-                            <a:srgbClr val="000000"/>
+                            <a:srgbClr val="0F172A"/>
                           </a:solidFill>
-                          <a:effectLst/>
-                          <a:latin typeface="Arial" panose="020B0604020202020204" pitchFamily="34" charset="0"/>
+                          <a:latin typeface="Segoe UI"/>
                         </a:rPr>
-                        <a:t>Lorem Ipsum</a:t>
+                        <a:t>Salesforce, Outlook Adaptive Cards, Slack, AWS Lambda + CloudFront, LangGraph</a:t>
                       </a:r>
-                      <a:r>
-                        <a:rPr lang="en-US" sz="1800" b="0" i="0" dirty="0">
-                          <a:solidFill>
-                            <a:srgbClr val="000000"/>
-                          </a:solidFill>
-                          <a:effectLst/>
-                          <a:latin typeface="Arial" panose="020B0604020202020204" pitchFamily="34" charset="0"/>
-                        </a:rPr>
-                        <a:t>​</a:t>
-                      </a:r>
-                      <a:endParaRPr lang="en-US" sz="1800" b="0" i="0" dirty="0">
-                        <a:solidFill>
-                          <a:srgbClr val="000000"/>
-                        </a:solidFill>
-                        <a:effectLst/>
-                      </a:endParaRPr>
                     </a:p>
                   </a:txBody>
                   <a:tcPr anchor="ctr">
@@ -15508,268 +15114,6 @@
       </p:graphicFrame>
       <p:sp>
         <p:nvSpPr>
-          <p:cNvPr id="5" name="Rectangle 1">
-            <a:extLst>
-              <a:ext uri="{FF2B5EF4-FFF2-40B4-BE49-F238E27FC236}">
-                <a16:creationId xmlns:a16="http://schemas.microsoft.com/office/drawing/2014/main" id="{FDDB8F6C-6FD2-1712-F7ED-DE2D595FD1C3}"/>
-              </a:ext>
-            </a:extLst>
-          </p:cNvPr>
-          <p:cNvSpPr>
-            <a:spLocks noChangeArrowheads="1"/>
-          </p:cNvSpPr>
-          <p:nvPr/>
-        </p:nvSpPr>
-        <p:spPr bwMode="auto">
-          <a:xfrm>
-            <a:off x="359999" y="859929"/>
-            <a:ext cx="10398312" cy="646331"/>
-          </a:xfrm>
-          <a:prstGeom prst="rect">
-            <a:avLst/>
-          </a:prstGeom>
-          <a:noFill/>
-          <a:ln>
-            <a:noFill/>
-          </a:ln>
-          <a:effectLst/>
-          <a:extLst>
-            <a:ext uri="{909E8E84-426E-40DD-AFC4-6F175D3DCCD1}">
-              <a14:hiddenFill xmlns:a14="http://schemas.microsoft.com/office/drawing/2010/main">
-                <a:solidFill>
-                  <a:schemeClr val="accent1"/>
-                </a:solidFill>
-              </a14:hiddenFill>
-            </a:ext>
-            <a:ext uri="{91240B29-F687-4F45-9708-019B960494DF}">
-              <a14:hiddenLine xmlns:a14="http://schemas.microsoft.com/office/drawing/2010/main" w="9525">
-                <a:solidFill>
-                  <a:schemeClr val="tx1"/>
-                </a:solidFill>
-                <a:miter lim="800000"/>
-                <a:headEnd/>
-                <a:tailEnd/>
-              </a14:hiddenLine>
-            </a:ext>
-            <a:ext uri="{AF507438-7753-43E0-B8FC-AC1667EBCBE1}">
-              <a14:hiddenEffects xmlns:a14="http://schemas.microsoft.com/office/drawing/2010/main">
-                <a:effectLst>
-                  <a:outerShdw dist="35921" dir="2700000" algn="ctr" rotWithShape="0">
-                    <a:schemeClr val="bg2"/>
-                  </a:outerShdw>
-                </a:effectLst>
-              </a14:hiddenEffects>
-            </a:ext>
-          </a:extLst>
-        </p:spPr>
-        <p:txBody>
-          <a:bodyPr vert="horz" wrap="square" lIns="91440" tIns="45720" rIns="91440" bIns="45720" numCol="1" anchor="ctr" anchorCtr="0" compatLnSpc="1">
-            <a:prstTxWarp prst="textNoShape">
-              <a:avLst/>
-            </a:prstTxWarp>
-            <a:spAutoFit/>
-          </a:bodyPr>
-          <a:lstStyle>
-            <a:lvl1pPr eaLnBrk="0" fontAlgn="base">
-              <a:spcBef>
-                <a:spcPct val="0"/>
-              </a:spcBef>
-              <a:spcAft>
-                <a:spcPct val="0"/>
-              </a:spcAft>
-              <a:defRPr>
-                <a:solidFill>
-                  <a:schemeClr val="tx1"/>
-                </a:solidFill>
-                <a:latin typeface="Arial" panose="020B0604020202020204" pitchFamily="34" charset="0"/>
-              </a:defRPr>
-            </a:lvl1pPr>
-            <a:lvl2pPr marL="457200" eaLnBrk="0" fontAlgn="base">
-              <a:spcBef>
-                <a:spcPct val="0"/>
-              </a:spcBef>
-              <a:spcAft>
-                <a:spcPct val="0"/>
-              </a:spcAft>
-              <a:defRPr>
-                <a:solidFill>
-                  <a:schemeClr val="tx1"/>
-                </a:solidFill>
-                <a:latin typeface="Arial" panose="020B0604020202020204" pitchFamily="34" charset="0"/>
-              </a:defRPr>
-            </a:lvl2pPr>
-            <a:lvl3pPr marL="914400" eaLnBrk="0" fontAlgn="base">
-              <a:spcBef>
-                <a:spcPct val="0"/>
-              </a:spcBef>
-              <a:spcAft>
-                <a:spcPct val="0"/>
-              </a:spcAft>
-              <a:defRPr>
-                <a:solidFill>
-                  <a:schemeClr val="tx1"/>
-                </a:solidFill>
-                <a:latin typeface="Arial" panose="020B0604020202020204" pitchFamily="34" charset="0"/>
-              </a:defRPr>
-            </a:lvl3pPr>
-            <a:lvl4pPr marL="1371600" eaLnBrk="0" fontAlgn="base">
-              <a:spcBef>
-                <a:spcPct val="0"/>
-              </a:spcBef>
-              <a:spcAft>
-                <a:spcPct val="0"/>
-              </a:spcAft>
-              <a:defRPr>
-                <a:solidFill>
-                  <a:schemeClr val="tx1"/>
-                </a:solidFill>
-                <a:latin typeface="Arial" panose="020B0604020202020204" pitchFamily="34" charset="0"/>
-              </a:defRPr>
-            </a:lvl4pPr>
-            <a:lvl5pPr marL="1828800" eaLnBrk="0" fontAlgn="base">
-              <a:spcBef>
-                <a:spcPct val="0"/>
-              </a:spcBef>
-              <a:spcAft>
-                <a:spcPct val="0"/>
-              </a:spcAft>
-              <a:defRPr>
-                <a:solidFill>
-                  <a:schemeClr val="tx1"/>
-                </a:solidFill>
-                <a:latin typeface="Arial" panose="020B0604020202020204" pitchFamily="34" charset="0"/>
-              </a:defRPr>
-            </a:lvl5pPr>
-            <a:lvl6pPr marL="2286000" eaLnBrk="0" fontAlgn="base">
-              <a:spcBef>
-                <a:spcPct val="0"/>
-              </a:spcBef>
-              <a:spcAft>
-                <a:spcPct val="0"/>
-              </a:spcAft>
-              <a:defRPr>
-                <a:solidFill>
-                  <a:schemeClr val="tx1"/>
-                </a:solidFill>
-                <a:latin typeface="Arial" panose="020B0604020202020204" pitchFamily="34" charset="0"/>
-              </a:defRPr>
-            </a:lvl6pPr>
-            <a:lvl7pPr marL="2743200" eaLnBrk="0" fontAlgn="base">
-              <a:spcBef>
-                <a:spcPct val="0"/>
-              </a:spcBef>
-              <a:spcAft>
-                <a:spcPct val="0"/>
-              </a:spcAft>
-              <a:defRPr>
-                <a:solidFill>
-                  <a:schemeClr val="tx1"/>
-                </a:solidFill>
-                <a:latin typeface="Arial" panose="020B0604020202020204" pitchFamily="34" charset="0"/>
-              </a:defRPr>
-            </a:lvl7pPr>
-            <a:lvl8pPr marL="3200400" eaLnBrk="0" fontAlgn="base">
-              <a:spcBef>
-                <a:spcPct val="0"/>
-              </a:spcBef>
-              <a:spcAft>
-                <a:spcPct val="0"/>
-              </a:spcAft>
-              <a:defRPr>
-                <a:solidFill>
-                  <a:schemeClr val="tx1"/>
-                </a:solidFill>
-                <a:latin typeface="Arial" panose="020B0604020202020204" pitchFamily="34" charset="0"/>
-              </a:defRPr>
-            </a:lvl8pPr>
-            <a:lvl9pPr marL="3657600" eaLnBrk="0" fontAlgn="base">
-              <a:spcBef>
-                <a:spcPct val="0"/>
-              </a:spcBef>
-              <a:spcAft>
-                <a:spcPct val="0"/>
-              </a:spcAft>
-              <a:defRPr>
-                <a:solidFill>
-                  <a:schemeClr val="tx1"/>
-                </a:solidFill>
-                <a:latin typeface="Arial" panose="020B0604020202020204" pitchFamily="34" charset="0"/>
-              </a:defRPr>
-            </a:lvl9pPr>
-          </a:lstStyle>
-          <a:p>
-            <a:pPr marL="0" marR="0" lvl="0" indent="0" algn="l" defTabSz="914400" rtl="0" eaLnBrk="0" fontAlgn="base" latinLnBrk="0" hangingPunct="0">
-              <a:lnSpc>
-                <a:spcPct val="100000"/>
-              </a:lnSpc>
-              <a:spcBef>
-                <a:spcPct val="0"/>
-              </a:spcBef>
-              <a:spcAft>
-                <a:spcPct val="0"/>
-              </a:spcAft>
-              <a:buClrTx/>
-              <a:buSzTx/>
-              <a:buFontTx/>
-              <a:buNone/>
-              <a:tabLst/>
-            </a:pPr>
-            <a:r>
-              <a:rPr kumimoji="0" lang="en-US" altLang="en-US" sz="1800" b="0" i="0" u="none" strike="noStrike" cap="none" normalizeH="0" baseline="0">
-                <a:ln>
-                  <a:noFill/>
-                </a:ln>
-                <a:solidFill>
-                  <a:srgbClr val="000000"/>
-                </a:solidFill>
-                <a:effectLst/>
-                <a:latin typeface="Times New Roman" panose="02020603050405020304" pitchFamily="18" charset="0"/>
-                <a:cs typeface="Times New Roman" panose="02020603050405020304" pitchFamily="18" charset="0"/>
-              </a:rPr>
-              <a:t> </a:t>
-            </a:r>
-            <a:endParaRPr kumimoji="0" lang="en-US" altLang="en-US" sz="1800" b="0" i="0" u="none" strike="noStrike" cap="none" normalizeH="0" baseline="0">
-              <a:ln>
-                <a:noFill/>
-              </a:ln>
-              <a:solidFill>
-                <a:schemeClr val="tx1"/>
-              </a:solidFill>
-              <a:effectLst/>
-            </a:endParaRPr>
-          </a:p>
-          <a:p>
-            <a:pPr marL="0" marR="0" lvl="0" indent="0" algn="l" defTabSz="914400" rtl="0" eaLnBrk="0" fontAlgn="base" latinLnBrk="0" hangingPunct="0">
-              <a:lnSpc>
-                <a:spcPct val="100000"/>
-              </a:lnSpc>
-              <a:spcBef>
-                <a:spcPct val="0"/>
-              </a:spcBef>
-              <a:spcAft>
-                <a:spcPct val="0"/>
-              </a:spcAft>
-              <a:buClrTx/>
-              <a:buSzTx/>
-              <a:buFontTx/>
-              <a:buNone/>
-              <a:tabLst/>
-            </a:pPr>
-            <a:endParaRPr kumimoji="0" lang="en-US" altLang="en-US" sz="1800" b="0" i="0" u="none" strike="noStrike" cap="none" normalizeH="0" baseline="0">
-              <a:ln>
-                <a:noFill/>
-              </a:ln>
-              <a:solidFill>
-                <a:schemeClr val="tx1"/>
-              </a:solidFill>
-              <a:effectLst/>
-              <a:latin typeface="Arial" panose="020B0604020202020204" pitchFamily="34" charset="0"/>
-            </a:endParaRPr>
-          </a:p>
-        </p:txBody>
-      </p:sp>
-      <p:sp>
-        <p:nvSpPr>
           <p:cNvPr id="6" name="Text Placeholder 25">
             <a:extLst>
               <a:ext uri="{FF2B5EF4-FFF2-40B4-BE49-F238E27FC236}">
@@ -16143,6 +15487,9 @@
             </a:pPr>
             <a:r>
               <a:rPr sz="1200" b="0">
+                <a:solidFill>
+                  <a:srgbClr val="0F172A"/>
+                </a:solidFill>
                 <a:latin typeface="Segoe UI"/>
               </a:rPr>
               <a:t>For the Opportunity Owner (AE):</a:t>
@@ -16152,6 +15499,9 @@
             <a:pPr algn="l"/>
             <a:r>
               <a:rPr sz="1200" b="0">
+                <a:solidFill>
+                  <a:srgbClr val="0F172A"/>
+                </a:solidFill>
                 <a:latin typeface="Segoe UI"/>
               </a:rPr>
               <a:t>  - No chasing managers: agent routes, robot sends, BPMN tracks.</a:t>
@@ -16161,6 +15511,9 @@
             <a:pPr algn="l"/>
             <a:r>
               <a:rPr sz="1200" b="0">
+                <a:solidFill>
+                  <a:srgbClr val="0F172A"/>
+                </a:solidFill>
                 <a:latin typeface="Segoe UI"/>
               </a:rPr>
               <a:t>  - Slack DM + Outlook summary with the full decision trail at the end.</a:t>
@@ -16170,6 +15523,9 @@
             <a:pPr algn="l"/>
             <a:r>
               <a:rPr sz="1200" b="0">
+                <a:solidFill>
+                  <a:srgbClr val="0F172A"/>
+                </a:solidFill>
                 <a:latin typeface="Segoe UI"/>
               </a:rPr>
               <a:t>  - Low-risk deals (&lt;=5% / &lt;=$50k) clear with ZERO human touch.</a:t>
@@ -16182,6 +15538,9 @@
             <a:pPr algn="l"/>
             <a:r>
               <a:rPr sz="1200" b="0">
+                <a:solidFill>
+                  <a:srgbClr val="0F172A"/>
+                </a:solidFill>
                 <a:latin typeface="Segoe UI"/>
               </a:rPr>
               <a:t>For the business:</a:t>
@@ -16191,6 +15550,9 @@
             <a:pPr algn="l"/>
             <a:r>
               <a:rPr sz="1200" b="0">
+                <a:solidFill>
+                  <a:srgbClr val="0F172A"/>
+                </a:solidFill>
                 <a:latin typeface="Segoe UI"/>
               </a:rPr>
               <a:t>  - Consistent policy applied identically via the risk-score formula.</a:t>
@@ -16200,6 +15562,9 @@
             <a:pPr algn="l"/>
             <a:r>
               <a:rPr sz="1200" b="0">
+                <a:solidFill>
+                  <a:srgbClr val="0F172A"/>
+                </a:solidFill>
                 <a:latin typeface="Segoe UI"/>
               </a:rPr>
               <a:t>  - Rejection short-circuits the chain (no wasted approver time).</a:t>
@@ -16209,280 +15574,12 @@
             <a:pPr algn="l"/>
             <a:r>
               <a:rPr sz="1200" b="0">
+                <a:solidFill>
+                  <a:srgbClr val="0F172A"/>
+                </a:solidFill>
                 <a:latin typeface="Segoe UI"/>
               </a:rPr>
               <a:t>  - Data Fabric logs the agent recommendation vs. each human decision.</a:t>
-            </a:r>
-          </a:p>
-        </p:txBody>
-      </p:sp>
-      <p:sp>
-        <p:nvSpPr>
-          <p:cNvPr id="8" name="Text Placeholder 25">
-            <a:extLst>
-              <a:ext uri="{FF2B5EF4-FFF2-40B4-BE49-F238E27FC236}">
-                <a16:creationId xmlns:a16="http://schemas.microsoft.com/office/drawing/2014/main" id="{41C52358-4F5E-423D-E7FA-F4BB97C68355}"/>
-              </a:ext>
-            </a:extLst>
-          </p:cNvPr>
-          <p:cNvSpPr>
-            <a:spLocks noGrp="1"/>
-          </p:cNvSpPr>
-          <p:nvPr/>
-        </p:nvSpPr>
-        <p:spPr>
-          <a:xfrm>
-            <a:off x="359999" y="810000"/>
-            <a:ext cx="5497831" cy="489737"/>
-          </a:xfrm>
-          <a:prstGeom prst="rect">
-            <a:avLst/>
-          </a:prstGeom>
-        </p:spPr>
-        <p:txBody>
-          <a:bodyPr vert="horz" lIns="0" tIns="0" rIns="0" bIns="0" rtlCol="0" anchor="b" anchorCtr="0">
-            <a:noAutofit/>
-          </a:bodyPr>
-          <a:lstStyle>
-            <a:lvl1pPr marL="0" indent="0" algn="l" defTabSz="457200" rtl="0" eaLnBrk="1" latinLnBrk="0" hangingPunct="1">
-              <a:lnSpc>
-                <a:spcPct val="90000"/>
-              </a:lnSpc>
-              <a:spcBef>
-                <a:spcPts val="500"/>
-              </a:spcBef>
-              <a:buFont typeface="Arial"/>
-              <a:buNone/>
-              <a:defRPr sz="2000" b="1" kern="1200" spc="-30" baseline="0">
-                <a:solidFill>
-                  <a:schemeClr val="tx1"/>
-                </a:solidFill>
-                <a:latin typeface="Arial"/>
-                <a:ea typeface="+mn-ea"/>
-                <a:cs typeface="Arial"/>
-              </a:defRPr>
-            </a:lvl1pPr>
-            <a:lvl2pPr marL="174625" indent="-174625" algn="l" defTabSz="457200" rtl="0" eaLnBrk="1" latinLnBrk="0" hangingPunct="1">
-              <a:spcBef>
-                <a:spcPts val="0"/>
-              </a:spcBef>
-              <a:buClr>
-                <a:schemeClr val="accent1"/>
-              </a:buClr>
-              <a:buFont typeface="Arial"/>
-              <a:buChar char="•"/>
-              <a:defRPr sz="1500" b="0" kern="1200" spc="-30">
-                <a:solidFill>
-                  <a:schemeClr val="tx1"/>
-                </a:solidFill>
-                <a:latin typeface="Arial"/>
-                <a:ea typeface="+mn-ea"/>
-                <a:cs typeface="Arial"/>
-              </a:defRPr>
-            </a:lvl2pPr>
-            <a:lvl3pPr marL="339725" indent="-165100" algn="l" defTabSz="457200" rtl="0" eaLnBrk="1" latinLnBrk="0" hangingPunct="1">
-              <a:spcBef>
-                <a:spcPts val="0"/>
-              </a:spcBef>
-              <a:buClr>
-                <a:schemeClr val="accent1"/>
-              </a:buClr>
-              <a:buFont typeface="Lucida Grande"/>
-              <a:buChar char="-"/>
-              <a:defRPr sz="1500" b="0" kern="1200" spc="-30">
-                <a:solidFill>
-                  <a:schemeClr val="tx1"/>
-                </a:solidFill>
-                <a:latin typeface="Arial"/>
-                <a:ea typeface="+mn-ea"/>
-                <a:cs typeface="Arial"/>
-              </a:defRPr>
-            </a:lvl3pPr>
-            <a:lvl4pPr marL="512763" indent="-173038" algn="l" defTabSz="457200" rtl="0" eaLnBrk="1" latinLnBrk="0" hangingPunct="1">
-              <a:spcBef>
-                <a:spcPts val="0"/>
-              </a:spcBef>
-              <a:buClr>
-                <a:schemeClr val="accent1"/>
-              </a:buClr>
-              <a:buFont typeface="Arial"/>
-              <a:buChar char="•"/>
-              <a:defRPr sz="1500" b="0" kern="1200" spc="-30">
-                <a:solidFill>
-                  <a:schemeClr val="tx1"/>
-                </a:solidFill>
-                <a:latin typeface="Arial"/>
-                <a:ea typeface="+mn-ea"/>
-                <a:cs typeface="Arial"/>
-              </a:defRPr>
-            </a:lvl4pPr>
-            <a:lvl5pPr marL="687388" indent="-174625" algn="l" defTabSz="457200" rtl="0" eaLnBrk="1" latinLnBrk="0" hangingPunct="1">
-              <a:spcBef>
-                <a:spcPts val="0"/>
-              </a:spcBef>
-              <a:buClr>
-                <a:schemeClr val="accent1"/>
-              </a:buClr>
-              <a:buFont typeface="Lucida Grande"/>
-              <a:buChar char="-"/>
-              <a:defRPr sz="1500" b="0" kern="1200" spc="-30">
-                <a:solidFill>
-                  <a:schemeClr val="tx1"/>
-                </a:solidFill>
-                <a:latin typeface="Arial"/>
-                <a:ea typeface="+mn-ea"/>
-                <a:cs typeface="Arial"/>
-              </a:defRPr>
-            </a:lvl5pPr>
-            <a:lvl6pPr marL="2514600" indent="-228600" algn="l" defTabSz="457200" rtl="0" eaLnBrk="1" latinLnBrk="0" hangingPunct="1">
-              <a:spcBef>
-                <a:spcPct val="20000"/>
-              </a:spcBef>
-              <a:buFont typeface="Arial"/>
-              <a:buChar char="•"/>
-              <a:defRPr sz="2000" kern="1200">
-                <a:solidFill>
-                  <a:schemeClr val="tx1"/>
-                </a:solidFill>
-                <a:latin typeface="+mn-lt"/>
-                <a:ea typeface="+mn-ea"/>
-                <a:cs typeface="+mn-cs"/>
-              </a:defRPr>
-            </a:lvl6pPr>
-            <a:lvl7pPr marL="2971800" indent="-228600" algn="l" defTabSz="457200" rtl="0" eaLnBrk="1" latinLnBrk="0" hangingPunct="1">
-              <a:spcBef>
-                <a:spcPct val="20000"/>
-              </a:spcBef>
-              <a:buFont typeface="Arial"/>
-              <a:buChar char="•"/>
-              <a:defRPr sz="2000" kern="1200">
-                <a:solidFill>
-                  <a:schemeClr val="tx1"/>
-                </a:solidFill>
-                <a:latin typeface="+mn-lt"/>
-                <a:ea typeface="+mn-ea"/>
-                <a:cs typeface="+mn-cs"/>
-              </a:defRPr>
-            </a:lvl7pPr>
-            <a:lvl8pPr marL="3429000" indent="-228600" algn="l" defTabSz="457200" rtl="0" eaLnBrk="1" latinLnBrk="0" hangingPunct="1">
-              <a:spcBef>
-                <a:spcPct val="20000"/>
-              </a:spcBef>
-              <a:buFont typeface="Arial"/>
-              <a:buChar char="•"/>
-              <a:defRPr sz="2000" kern="1200">
-                <a:solidFill>
-                  <a:schemeClr val="tx1"/>
-                </a:solidFill>
-                <a:latin typeface="+mn-lt"/>
-                <a:ea typeface="+mn-ea"/>
-                <a:cs typeface="+mn-cs"/>
-              </a:defRPr>
-            </a:lvl8pPr>
-            <a:lvl9pPr marL="3886200" indent="-228600" algn="l" defTabSz="457200" rtl="0" eaLnBrk="1" latinLnBrk="0" hangingPunct="1">
-              <a:spcBef>
-                <a:spcPct val="20000"/>
-              </a:spcBef>
-              <a:buFont typeface="Arial"/>
-              <a:buChar char="•"/>
-              <a:defRPr sz="2000" kern="1200">
-                <a:solidFill>
-                  <a:schemeClr val="tx1"/>
-                </a:solidFill>
-                <a:latin typeface="+mn-lt"/>
-                <a:ea typeface="+mn-ea"/>
-                <a:cs typeface="+mn-cs"/>
-              </a:defRPr>
-            </a:lvl9pPr>
-          </a:lstStyle>
-          <a:p>
-            <a:pPr algn="l"/>
-            <a:r>
-              <a:rPr sz="1150" b="1">
-                <a:latin typeface="Segoe UI"/>
-              </a:rPr>
-              <a:t>Technologies (verified live Jun 22 2026):</a:t>
-            </a:r>
-          </a:p>
-          <a:p>
-            <a:pPr algn="l"/>
-            <a:r>
-              <a:rPr sz="1150" b="0">
-                <a:latin typeface="Segoe UI"/>
-              </a:rPr>
-              <a:t>  Coded Agents (Python + LangGraph): plan, render, process_response</a:t>
-            </a:r>
-          </a:p>
-          <a:p>
-            <a:pPr algn="l"/>
-            <a:r>
-              <a:rPr sz="1150" b="0">
-                <a:latin typeface="Segoe UI"/>
-              </a:rPr>
-              <a:t>  Maestro BPMN 2.0: sequential multi-instance loop, completionCondition</a:t>
-            </a:r>
-          </a:p>
-          <a:p>
-            <a:pPr algn="l"/>
-            <a:r>
-              <a:rPr sz="1150" b="0">
-                <a:latin typeface="Segoe UI"/>
-              </a:rPr>
-              <a:t>  WaitDecision Robot (UiPath RPA + Persistence): all three channels</a:t>
-            </a:r>
-          </a:p>
-          <a:p>
-            <a:pPr algn="l"/>
-            <a:r>
-              <a:rPr sz="1150" b="0">
-                <a:latin typeface="Segoe UI"/>
-              </a:rPr>
-              <a:t>  Action Center: external task 'wait for task' (Deal Desk catalog)</a:t>
-            </a:r>
-          </a:p>
-          <a:p>
-            <a:pPr algn="l"/>
-            <a:r>
-              <a:rPr sz="1150" b="0">
-                <a:latin typeface="Segoe UI"/>
-              </a:rPr>
-              <a:t>  Outlook Adaptive Card: originator 61fed71d, Action.Http buttons, HTML fallback</a:t>
-            </a:r>
-          </a:p>
-          <a:p>
-            <a:pPr algn="l"/>
-            <a:r>
-              <a:rPr sz="1150" b="0">
-                <a:latin typeface="Segoe UI"/>
-              </a:rPr>
-              <a:t>  Slack Block Kit: DM to approver + requester</a:t>
-            </a:r>
-          </a:p>
-          <a:p>
-            <a:pPr algn="l"/>
-            <a:r>
-              <a:rPr sz="1150" b="0">
-                <a:latin typeface="Segoe UI"/>
-              </a:rPr>
-              <a:t>  AWS Lambda + CloudFront: HITL bridge for the approval loop</a:t>
-            </a:r>
-          </a:p>
-          <a:p>
-            <a:pPr algn="l"/>
-            <a:r>
-              <a:rPr sz="1150" b="0">
-                <a:latin typeface="Segoe UI"/>
-              </a:rPr>
-              <a:t>  AgentHub MCP: Salesforce DealDesk MCP (live IS, read-only SOQL)</a:t>
-            </a:r>
-          </a:p>
-          <a:p>
-            <a:pPr algn="l"/>
-            <a:r>
-              <a:rPr sz="1150" b="0">
-                <a:latin typeface="Segoe UI"/>
-              </a:rPr>
-              <a:t>  Data Fabric: ApprovalAudit; deployed to Shared/DealDeskApprovalGlobal</a:t>
             </a:r>
           </a:p>
         </p:txBody>
@@ -16568,268 +15665,6 @@
       </p:sp>
       <p:sp>
         <p:nvSpPr>
-          <p:cNvPr id="5" name="Rectangle 1">
-            <a:extLst>
-              <a:ext uri="{FF2B5EF4-FFF2-40B4-BE49-F238E27FC236}">
-                <a16:creationId xmlns:a16="http://schemas.microsoft.com/office/drawing/2014/main" id="{D988C2DD-493B-5D96-F19B-E505FAFF2D0F}"/>
-              </a:ext>
-            </a:extLst>
-          </p:cNvPr>
-          <p:cNvSpPr>
-            <a:spLocks noChangeArrowheads="1"/>
-          </p:cNvSpPr>
-          <p:nvPr/>
-        </p:nvSpPr>
-        <p:spPr bwMode="auto">
-          <a:xfrm>
-            <a:off x="359999" y="859929"/>
-            <a:ext cx="10398312" cy="646331"/>
-          </a:xfrm>
-          <a:prstGeom prst="rect">
-            <a:avLst/>
-          </a:prstGeom>
-          <a:noFill/>
-          <a:ln>
-            <a:noFill/>
-          </a:ln>
-          <a:effectLst/>
-          <a:extLst>
-            <a:ext uri="{909E8E84-426E-40DD-AFC4-6F175D3DCCD1}">
-              <a14:hiddenFill xmlns:a14="http://schemas.microsoft.com/office/drawing/2010/main">
-                <a:solidFill>
-                  <a:schemeClr val="accent1"/>
-                </a:solidFill>
-              </a14:hiddenFill>
-            </a:ext>
-            <a:ext uri="{91240B29-F687-4F45-9708-019B960494DF}">
-              <a14:hiddenLine xmlns:a14="http://schemas.microsoft.com/office/drawing/2010/main" w="9525">
-                <a:solidFill>
-                  <a:schemeClr val="tx1"/>
-                </a:solidFill>
-                <a:miter lim="800000"/>
-                <a:headEnd/>
-                <a:tailEnd/>
-              </a14:hiddenLine>
-            </a:ext>
-            <a:ext uri="{AF507438-7753-43E0-B8FC-AC1667EBCBE1}">
-              <a14:hiddenEffects xmlns:a14="http://schemas.microsoft.com/office/drawing/2010/main">
-                <a:effectLst>
-                  <a:outerShdw dist="35921" dir="2700000" algn="ctr" rotWithShape="0">
-                    <a:schemeClr val="bg2"/>
-                  </a:outerShdw>
-                </a:effectLst>
-              </a14:hiddenEffects>
-            </a:ext>
-          </a:extLst>
-        </p:spPr>
-        <p:txBody>
-          <a:bodyPr vert="horz" wrap="square" lIns="91440" tIns="45720" rIns="91440" bIns="45720" numCol="1" anchor="ctr" anchorCtr="0" compatLnSpc="1">
-            <a:prstTxWarp prst="textNoShape">
-              <a:avLst/>
-            </a:prstTxWarp>
-            <a:spAutoFit/>
-          </a:bodyPr>
-          <a:lstStyle>
-            <a:lvl1pPr eaLnBrk="0" fontAlgn="base">
-              <a:spcBef>
-                <a:spcPct val="0"/>
-              </a:spcBef>
-              <a:spcAft>
-                <a:spcPct val="0"/>
-              </a:spcAft>
-              <a:defRPr>
-                <a:solidFill>
-                  <a:schemeClr val="tx1"/>
-                </a:solidFill>
-                <a:latin typeface="Arial" panose="020B0604020202020204" pitchFamily="34" charset="0"/>
-              </a:defRPr>
-            </a:lvl1pPr>
-            <a:lvl2pPr marL="457200" eaLnBrk="0" fontAlgn="base">
-              <a:spcBef>
-                <a:spcPct val="0"/>
-              </a:spcBef>
-              <a:spcAft>
-                <a:spcPct val="0"/>
-              </a:spcAft>
-              <a:defRPr>
-                <a:solidFill>
-                  <a:schemeClr val="tx1"/>
-                </a:solidFill>
-                <a:latin typeface="Arial" panose="020B0604020202020204" pitchFamily="34" charset="0"/>
-              </a:defRPr>
-            </a:lvl2pPr>
-            <a:lvl3pPr marL="914400" eaLnBrk="0" fontAlgn="base">
-              <a:spcBef>
-                <a:spcPct val="0"/>
-              </a:spcBef>
-              <a:spcAft>
-                <a:spcPct val="0"/>
-              </a:spcAft>
-              <a:defRPr>
-                <a:solidFill>
-                  <a:schemeClr val="tx1"/>
-                </a:solidFill>
-                <a:latin typeface="Arial" panose="020B0604020202020204" pitchFamily="34" charset="0"/>
-              </a:defRPr>
-            </a:lvl3pPr>
-            <a:lvl4pPr marL="1371600" eaLnBrk="0" fontAlgn="base">
-              <a:spcBef>
-                <a:spcPct val="0"/>
-              </a:spcBef>
-              <a:spcAft>
-                <a:spcPct val="0"/>
-              </a:spcAft>
-              <a:defRPr>
-                <a:solidFill>
-                  <a:schemeClr val="tx1"/>
-                </a:solidFill>
-                <a:latin typeface="Arial" panose="020B0604020202020204" pitchFamily="34" charset="0"/>
-              </a:defRPr>
-            </a:lvl4pPr>
-            <a:lvl5pPr marL="1828800" eaLnBrk="0" fontAlgn="base">
-              <a:spcBef>
-                <a:spcPct val="0"/>
-              </a:spcBef>
-              <a:spcAft>
-                <a:spcPct val="0"/>
-              </a:spcAft>
-              <a:defRPr>
-                <a:solidFill>
-                  <a:schemeClr val="tx1"/>
-                </a:solidFill>
-                <a:latin typeface="Arial" panose="020B0604020202020204" pitchFamily="34" charset="0"/>
-              </a:defRPr>
-            </a:lvl5pPr>
-            <a:lvl6pPr marL="2286000" eaLnBrk="0" fontAlgn="base">
-              <a:spcBef>
-                <a:spcPct val="0"/>
-              </a:spcBef>
-              <a:spcAft>
-                <a:spcPct val="0"/>
-              </a:spcAft>
-              <a:defRPr>
-                <a:solidFill>
-                  <a:schemeClr val="tx1"/>
-                </a:solidFill>
-                <a:latin typeface="Arial" panose="020B0604020202020204" pitchFamily="34" charset="0"/>
-              </a:defRPr>
-            </a:lvl6pPr>
-            <a:lvl7pPr marL="2743200" eaLnBrk="0" fontAlgn="base">
-              <a:spcBef>
-                <a:spcPct val="0"/>
-              </a:spcBef>
-              <a:spcAft>
-                <a:spcPct val="0"/>
-              </a:spcAft>
-              <a:defRPr>
-                <a:solidFill>
-                  <a:schemeClr val="tx1"/>
-                </a:solidFill>
-                <a:latin typeface="Arial" panose="020B0604020202020204" pitchFamily="34" charset="0"/>
-              </a:defRPr>
-            </a:lvl7pPr>
-            <a:lvl8pPr marL="3200400" eaLnBrk="0" fontAlgn="base">
-              <a:spcBef>
-                <a:spcPct val="0"/>
-              </a:spcBef>
-              <a:spcAft>
-                <a:spcPct val="0"/>
-              </a:spcAft>
-              <a:defRPr>
-                <a:solidFill>
-                  <a:schemeClr val="tx1"/>
-                </a:solidFill>
-                <a:latin typeface="Arial" panose="020B0604020202020204" pitchFamily="34" charset="0"/>
-              </a:defRPr>
-            </a:lvl8pPr>
-            <a:lvl9pPr marL="3657600" eaLnBrk="0" fontAlgn="base">
-              <a:spcBef>
-                <a:spcPct val="0"/>
-              </a:spcBef>
-              <a:spcAft>
-                <a:spcPct val="0"/>
-              </a:spcAft>
-              <a:defRPr>
-                <a:solidFill>
-                  <a:schemeClr val="tx1"/>
-                </a:solidFill>
-                <a:latin typeface="Arial" panose="020B0604020202020204" pitchFamily="34" charset="0"/>
-              </a:defRPr>
-            </a:lvl9pPr>
-          </a:lstStyle>
-          <a:p>
-            <a:pPr marL="0" marR="0" lvl="0" indent="0" algn="l" defTabSz="914400" rtl="0" eaLnBrk="0" fontAlgn="base" latinLnBrk="0" hangingPunct="0">
-              <a:lnSpc>
-                <a:spcPct val="100000"/>
-              </a:lnSpc>
-              <a:spcBef>
-                <a:spcPct val="0"/>
-              </a:spcBef>
-              <a:spcAft>
-                <a:spcPct val="0"/>
-              </a:spcAft>
-              <a:buClrTx/>
-              <a:buSzTx/>
-              <a:buFontTx/>
-              <a:buNone/>
-              <a:tabLst/>
-            </a:pPr>
-            <a:r>
-              <a:rPr kumimoji="0" lang="en-US" altLang="en-US" sz="1800" b="0" i="0" u="none" strike="noStrike" cap="none" normalizeH="0" baseline="0">
-                <a:ln>
-                  <a:noFill/>
-                </a:ln>
-                <a:solidFill>
-                  <a:srgbClr val="000000"/>
-                </a:solidFill>
-                <a:effectLst/>
-                <a:latin typeface="Times New Roman" panose="02020603050405020304" pitchFamily="18" charset="0"/>
-                <a:cs typeface="Times New Roman" panose="02020603050405020304" pitchFamily="18" charset="0"/>
-              </a:rPr>
-              <a:t> </a:t>
-            </a:r>
-            <a:endParaRPr kumimoji="0" lang="en-US" altLang="en-US" sz="1800" b="0" i="0" u="none" strike="noStrike" cap="none" normalizeH="0" baseline="0">
-              <a:ln>
-                <a:noFill/>
-              </a:ln>
-              <a:solidFill>
-                <a:schemeClr val="tx1"/>
-              </a:solidFill>
-              <a:effectLst/>
-            </a:endParaRPr>
-          </a:p>
-          <a:p>
-            <a:pPr marL="0" marR="0" lvl="0" indent="0" algn="l" defTabSz="914400" rtl="0" eaLnBrk="0" fontAlgn="base" latinLnBrk="0" hangingPunct="0">
-              <a:lnSpc>
-                <a:spcPct val="100000"/>
-              </a:lnSpc>
-              <a:spcBef>
-                <a:spcPct val="0"/>
-              </a:spcBef>
-              <a:spcAft>
-                <a:spcPct val="0"/>
-              </a:spcAft>
-              <a:buClrTx/>
-              <a:buSzTx/>
-              <a:buFontTx/>
-              <a:buNone/>
-              <a:tabLst/>
-            </a:pPr>
-            <a:endParaRPr kumimoji="0" lang="en-US" altLang="en-US" sz="1800" b="0" i="0" u="none" strike="noStrike" cap="none" normalizeH="0" baseline="0">
-              <a:ln>
-                <a:noFill/>
-              </a:ln>
-              <a:solidFill>
-                <a:schemeClr val="tx1"/>
-              </a:solidFill>
-              <a:effectLst/>
-              <a:latin typeface="Arial" panose="020B0604020202020204" pitchFamily="34" charset="0"/>
-            </a:endParaRPr>
-          </a:p>
-        </p:txBody>
-      </p:sp>
-      <p:sp>
-        <p:nvSpPr>
           <p:cNvPr id="2" name="Title 2">
             <a:extLst>
               <a:ext uri="{FF2B5EF4-FFF2-40B4-BE49-F238E27FC236}">
@@ -17114,15 +15949,15 @@
         </p:nvSpPr>
         <p:spPr>
           <a:xfrm>
-            <a:off x="359999" y="1506260"/>
-            <a:ext cx="11459302" cy="4426764"/>
+            <a:off x="365760" y="1371600"/>
+            <a:ext cx="6035040" cy="4846320"/>
           </a:xfrm>
           <a:prstGeom prst="rect">
             <a:avLst/>
           </a:prstGeom>
         </p:spPr>
         <p:txBody>
-          <a:bodyPr/>
+          <a:bodyPr wrap="square"/>
           <a:lstStyle>
             <a:defPPr>
               <a:defRPr lang="en-US"/>
@@ -17278,10 +16113,13 @@
           <a:p>
             <a:pPr algn="l"/>
             <a:r>
-              <a:rPr sz="1000" b="0">
+              <a:rPr sz="1100">
+                <a:solidFill>
+                  <a:srgbClr val="0F172A"/>
+                </a:solidFill>
                 <a:latin typeface="Segoe UI"/>
               </a:rPr>
-              <a:t>Salesforce event -&gt; Maestro BPMN -&gt; plan agent:</a:t>
+              <a:t>Salesforce opportunity change starts the Maestro BPMN.</a:t>
             </a:r>
             <a:endParaRPr lang="en-US" sz="1800" b="0" dirty="0">
               <a:solidFill>
@@ -17290,121 +16128,152 @@
             </a:endParaRPr>
           </a:p>
           <a:p>
-            <a:pPr algn="l"/>
-            <a:r>
-              <a:rPr sz="1000" b="0">
+            <a:r>
+              <a:rPr sz="1100">
+                <a:solidFill>
+                  <a:srgbClr val="0F172A"/>
+                </a:solidFill>
                 <a:latin typeface="Segoe UI"/>
               </a:rPr>
-              <a:t>  AgentHub MCP queries live Salesforce; org chart -&gt; approver chain</a:t>
-            </a:r>
-          </a:p>
-          <a:p>
-            <a:pPr algn="l"/>
-            <a:r>
-              <a:rPr sz="1000" b="0">
+              <a:t>plan agent: live Salesforce (AgentHub MCP) + org chart</a:t>
+            </a:r>
+          </a:p>
+          <a:p>
+            <a:r>
+              <a:rPr sz="1100">
+                <a:solidFill>
+                  <a:srgbClr val="0F172A"/>
+                </a:solidFill>
                 <a:latin typeface="Segoe UI"/>
               </a:rPr>
-              <a:t>  risk_score + LLM reasoning -&gt; RoutingPlan (disposition + rationale + chain)</a:t>
-            </a:r>
-          </a:p>
-          <a:p>
-            <a:pPr algn="l"/>
-          </a:p>
-          <a:p>
-            <a:pPr algn="l"/>
-            <a:r>
-              <a:rPr sz="1000" b="0">
+              <a:t>   -&gt; risk score + LLM rationale + approver chain</a:t>
+            </a:r>
+          </a:p>
+          <a:p>
+            <a:r>
+              <a:rPr sz="1100">
+                <a:solidFill>
+                  <a:srgbClr val="0F172A"/>
+                </a:solidFill>
                 <a:latin typeface="Segoe UI"/>
               </a:rPr>
               <a:t>Disposition gateway:</a:t>
             </a:r>
           </a:p>
           <a:p>
-            <a:pPr algn="l"/>
-            <a:r>
-              <a:rPr sz="1000" b="0">
+            <a:r>
+              <a:rPr sz="1100">
+                <a:solidFill>
+                  <a:srgbClr val="0F172A"/>
+                </a:solidFill>
                 <a:latin typeface="Segoe UI"/>
               </a:rPr>
-              <a:t>  auto_approve   -&gt; Slack + Outlook to AE + Data Fabric audit (zero touch)</a:t>
-            </a:r>
-          </a:p>
-          <a:p>
-            <a:pPr algn="l"/>
-            <a:r>
-              <a:rPr sz="1000" b="0">
+              <a:t>   auto_approve  -&gt; Slack + Outlook, audit (zero touch)</a:t>
+            </a:r>
+          </a:p>
+          <a:p>
+            <a:r>
+              <a:rPr sz="1100">
+                <a:solidFill>
+                  <a:srgbClr val="0F172A"/>
+                </a:solidFill>
                 <a:latin typeface="Segoe UI"/>
               </a:rPr>
-              <a:t>  exception      -&gt; immediate human review</a:t>
-            </a:r>
-          </a:p>
-          <a:p>
-            <a:pPr algn="l"/>
-            <a:r>
-              <a:rPr sz="1000" b="0">
+              <a:t>   needs_approval -&gt; sequential approver loop:</a:t>
+            </a:r>
+          </a:p>
+          <a:p>
+            <a:r>
+              <a:rPr sz="1100">
+                <a:solidFill>
+                  <a:srgbClr val="0F172A"/>
+                </a:solidFill>
                 <a:latin typeface="Segoe UI"/>
               </a:rPr>
-              <a:t>  needs_approval -&gt; sequential approver loop (per approver):</a:t>
-            </a:r>
-          </a:p>
-          <a:p>
-            <a:pPr algn="l"/>
-            <a:r>
-              <a:rPr sz="1000" b="0">
+              <a:t>      render -&gt; WaitDecision Robot fires 3 channels</a:t>
+            </a:r>
+          </a:p>
+          <a:p>
+            <a:r>
+              <a:rPr sz="1100">
+                <a:solidFill>
+                  <a:srgbClr val="0F172A"/>
+                </a:solidFill>
                 <a:latin typeface="Segoe UI"/>
               </a:rPr>
-              <a:t>    render agent builds the approval payload</a:t>
-            </a:r>
-          </a:p>
-          <a:p>
-            <a:pPr algn="l"/>
-            <a:r>
-              <a:rPr sz="1000" b="0">
+              <a:t>      (Outlook Adaptive Card + Slack + Action Center)</a:t>
+            </a:r>
+          </a:p>
+          <a:p>
+            <a:r>
+              <a:rPr sz="1100">
+                <a:solidFill>
+                  <a:srgbClr val="0F172A"/>
+                </a:solidFill>
                 <a:latin typeface="Segoe UI"/>
               </a:rPr>
-              <a:t>    WaitDecision Robot: Outlook Adaptive Card + Slack DM + Action Center task</a:t>
-            </a:r>
-          </a:p>
-          <a:p>
-            <a:pPr algn="l"/>
-            <a:r>
-              <a:rPr sz="1000" b="0">
+              <a:t>      AWS Lambda HITL bridge mints token; Persistence wait</a:t>
+            </a:r>
+          </a:p>
+          <a:p>
+            <a:r>
+              <a:rPr sz="1100">
+                <a:solidFill>
+                  <a:srgbClr val="0F172A"/>
+                </a:solidFill>
                 <a:latin typeface="Segoe UI"/>
               </a:rPr>
-              <a:t>    AWS Lambda HITL bridge mints token; suspend via UiPath.Persistence</a:t>
-            </a:r>
-          </a:p>
-          <a:p>
-            <a:pPr algn="l"/>
-            <a:r>
-              <a:rPr sz="1000" b="0">
+              <a:t>      any channel resolves; rejection short-circuits</a:t>
+            </a:r>
+          </a:p>
+          <a:p>
+            <a:r>
+              <a:rPr sz="1100">
+                <a:solidFill>
+                  <a:srgbClr val="0F172A"/>
+                </a:solidFill>
                 <a:latin typeface="Segoe UI"/>
               </a:rPr>
-              <a:t>    Approver decides on any channel -&gt; robot resumes -&gt; process_response</a:t>
-            </a:r>
-          </a:p>
-          <a:p>
-            <a:pPr algn="l"/>
-            <a:r>
-              <a:rPr sz="1000" b="0">
+              <a:t>process_response interprets the decisions</a:t>
+            </a:r>
+          </a:p>
+          <a:p>
+            <a:r>
+              <a:rPr sz="1100">
+                <a:solidFill>
+                  <a:srgbClr val="0F172A"/>
+                </a:solidFill>
                 <a:latin typeface="Segoe UI"/>
               </a:rPr>
-              <a:t>    Rejection short-circuits (BPMN completionCondition)</a:t>
-            </a:r>
-          </a:p>
-          <a:p>
-            <a:pPr algn="l"/>
-          </a:p>
-          <a:p>
-            <a:pPr algn="l"/>
-            <a:r>
-              <a:rPr sz="1000" b="0">
-                <a:latin typeface="Segoe UI"/>
-              </a:rPr>
-              <a:t>On completion: Slack DM + Outlook summary to AE -&gt; Data Fabric ApprovalAudit</a:t>
+              <a:t>   -&gt; Slack + Outlook summary -&gt; Data Fabric ApprovalAudit</a:t>
             </a:r>
           </a:p>
         </p:txBody>
       </p:sp>
+      <p:pic>
+        <p:nvPicPr>
+          <p:cNvPr id="5" name="Picture 4" descr="01-architecture.png"/>
+          <p:cNvPicPr>
+            <a:picLocks noChangeAspect="1"/>
+          </p:cNvPicPr>
+          <p:nvPr/>
+        </p:nvPicPr>
+        <p:blipFill>
+          <a:blip r:embed="rId2"/>
+          <a:stretch>
+            <a:fillRect/>
+          </a:stretch>
+        </p:blipFill>
+        <p:spPr>
+          <a:xfrm>
+            <a:off x="6766560" y="1280160"/>
+            <a:ext cx="3585127" cy="5120640"/>
+          </a:xfrm>
+          <a:prstGeom prst="rect">
+            <a:avLst/>
+          </a:prstGeom>
+        </p:spPr>
+      </p:pic>
     </p:spTree>
     <p:extLst>
       <p:ext uri="{BB962C8B-B14F-4D97-AF65-F5344CB8AC3E}">
@@ -17486,268 +16355,6 @@
       </p:sp>
       <p:sp>
         <p:nvSpPr>
-          <p:cNvPr id="5" name="Rectangle 1">
-            <a:extLst>
-              <a:ext uri="{FF2B5EF4-FFF2-40B4-BE49-F238E27FC236}">
-                <a16:creationId xmlns:a16="http://schemas.microsoft.com/office/drawing/2014/main" id="{01843E0A-2036-C699-04BE-44B828C31B55}"/>
-              </a:ext>
-            </a:extLst>
-          </p:cNvPr>
-          <p:cNvSpPr>
-            <a:spLocks noChangeArrowheads="1"/>
-          </p:cNvSpPr>
-          <p:nvPr/>
-        </p:nvSpPr>
-        <p:spPr bwMode="auto">
-          <a:xfrm>
-            <a:off x="359999" y="859929"/>
-            <a:ext cx="10398312" cy="646331"/>
-          </a:xfrm>
-          <a:prstGeom prst="rect">
-            <a:avLst/>
-          </a:prstGeom>
-          <a:noFill/>
-          <a:ln>
-            <a:noFill/>
-          </a:ln>
-          <a:effectLst/>
-          <a:extLst>
-            <a:ext uri="{909E8E84-426E-40DD-AFC4-6F175D3DCCD1}">
-              <a14:hiddenFill xmlns:a14="http://schemas.microsoft.com/office/drawing/2010/main">
-                <a:solidFill>
-                  <a:schemeClr val="accent1"/>
-                </a:solidFill>
-              </a14:hiddenFill>
-            </a:ext>
-            <a:ext uri="{91240B29-F687-4F45-9708-019B960494DF}">
-              <a14:hiddenLine xmlns:a14="http://schemas.microsoft.com/office/drawing/2010/main" w="9525">
-                <a:solidFill>
-                  <a:schemeClr val="tx1"/>
-                </a:solidFill>
-                <a:miter lim="800000"/>
-                <a:headEnd/>
-                <a:tailEnd/>
-              </a14:hiddenLine>
-            </a:ext>
-            <a:ext uri="{AF507438-7753-43E0-B8FC-AC1667EBCBE1}">
-              <a14:hiddenEffects xmlns:a14="http://schemas.microsoft.com/office/drawing/2010/main">
-                <a:effectLst>
-                  <a:outerShdw dist="35921" dir="2700000" algn="ctr" rotWithShape="0">
-                    <a:schemeClr val="bg2"/>
-                  </a:outerShdw>
-                </a:effectLst>
-              </a14:hiddenEffects>
-            </a:ext>
-          </a:extLst>
-        </p:spPr>
-        <p:txBody>
-          <a:bodyPr vert="horz" wrap="square" lIns="91440" tIns="45720" rIns="91440" bIns="45720" numCol="1" anchor="ctr" anchorCtr="0" compatLnSpc="1">
-            <a:prstTxWarp prst="textNoShape">
-              <a:avLst/>
-            </a:prstTxWarp>
-            <a:spAutoFit/>
-          </a:bodyPr>
-          <a:lstStyle>
-            <a:lvl1pPr eaLnBrk="0" fontAlgn="base">
-              <a:spcBef>
-                <a:spcPct val="0"/>
-              </a:spcBef>
-              <a:spcAft>
-                <a:spcPct val="0"/>
-              </a:spcAft>
-              <a:defRPr>
-                <a:solidFill>
-                  <a:schemeClr val="tx1"/>
-                </a:solidFill>
-                <a:latin typeface="Arial" panose="020B0604020202020204" pitchFamily="34" charset="0"/>
-              </a:defRPr>
-            </a:lvl1pPr>
-            <a:lvl2pPr marL="457200" eaLnBrk="0" fontAlgn="base">
-              <a:spcBef>
-                <a:spcPct val="0"/>
-              </a:spcBef>
-              <a:spcAft>
-                <a:spcPct val="0"/>
-              </a:spcAft>
-              <a:defRPr>
-                <a:solidFill>
-                  <a:schemeClr val="tx1"/>
-                </a:solidFill>
-                <a:latin typeface="Arial" panose="020B0604020202020204" pitchFamily="34" charset="0"/>
-              </a:defRPr>
-            </a:lvl2pPr>
-            <a:lvl3pPr marL="914400" eaLnBrk="0" fontAlgn="base">
-              <a:spcBef>
-                <a:spcPct val="0"/>
-              </a:spcBef>
-              <a:spcAft>
-                <a:spcPct val="0"/>
-              </a:spcAft>
-              <a:defRPr>
-                <a:solidFill>
-                  <a:schemeClr val="tx1"/>
-                </a:solidFill>
-                <a:latin typeface="Arial" panose="020B0604020202020204" pitchFamily="34" charset="0"/>
-              </a:defRPr>
-            </a:lvl3pPr>
-            <a:lvl4pPr marL="1371600" eaLnBrk="0" fontAlgn="base">
-              <a:spcBef>
-                <a:spcPct val="0"/>
-              </a:spcBef>
-              <a:spcAft>
-                <a:spcPct val="0"/>
-              </a:spcAft>
-              <a:defRPr>
-                <a:solidFill>
-                  <a:schemeClr val="tx1"/>
-                </a:solidFill>
-                <a:latin typeface="Arial" panose="020B0604020202020204" pitchFamily="34" charset="0"/>
-              </a:defRPr>
-            </a:lvl4pPr>
-            <a:lvl5pPr marL="1828800" eaLnBrk="0" fontAlgn="base">
-              <a:spcBef>
-                <a:spcPct val="0"/>
-              </a:spcBef>
-              <a:spcAft>
-                <a:spcPct val="0"/>
-              </a:spcAft>
-              <a:defRPr>
-                <a:solidFill>
-                  <a:schemeClr val="tx1"/>
-                </a:solidFill>
-                <a:latin typeface="Arial" panose="020B0604020202020204" pitchFamily="34" charset="0"/>
-              </a:defRPr>
-            </a:lvl5pPr>
-            <a:lvl6pPr marL="2286000" eaLnBrk="0" fontAlgn="base">
-              <a:spcBef>
-                <a:spcPct val="0"/>
-              </a:spcBef>
-              <a:spcAft>
-                <a:spcPct val="0"/>
-              </a:spcAft>
-              <a:defRPr>
-                <a:solidFill>
-                  <a:schemeClr val="tx1"/>
-                </a:solidFill>
-                <a:latin typeface="Arial" panose="020B0604020202020204" pitchFamily="34" charset="0"/>
-              </a:defRPr>
-            </a:lvl6pPr>
-            <a:lvl7pPr marL="2743200" eaLnBrk="0" fontAlgn="base">
-              <a:spcBef>
-                <a:spcPct val="0"/>
-              </a:spcBef>
-              <a:spcAft>
-                <a:spcPct val="0"/>
-              </a:spcAft>
-              <a:defRPr>
-                <a:solidFill>
-                  <a:schemeClr val="tx1"/>
-                </a:solidFill>
-                <a:latin typeface="Arial" panose="020B0604020202020204" pitchFamily="34" charset="0"/>
-              </a:defRPr>
-            </a:lvl7pPr>
-            <a:lvl8pPr marL="3200400" eaLnBrk="0" fontAlgn="base">
-              <a:spcBef>
-                <a:spcPct val="0"/>
-              </a:spcBef>
-              <a:spcAft>
-                <a:spcPct val="0"/>
-              </a:spcAft>
-              <a:defRPr>
-                <a:solidFill>
-                  <a:schemeClr val="tx1"/>
-                </a:solidFill>
-                <a:latin typeface="Arial" panose="020B0604020202020204" pitchFamily="34" charset="0"/>
-              </a:defRPr>
-            </a:lvl8pPr>
-            <a:lvl9pPr marL="3657600" eaLnBrk="0" fontAlgn="base">
-              <a:spcBef>
-                <a:spcPct val="0"/>
-              </a:spcBef>
-              <a:spcAft>
-                <a:spcPct val="0"/>
-              </a:spcAft>
-              <a:defRPr>
-                <a:solidFill>
-                  <a:schemeClr val="tx1"/>
-                </a:solidFill>
-                <a:latin typeface="Arial" panose="020B0604020202020204" pitchFamily="34" charset="0"/>
-              </a:defRPr>
-            </a:lvl9pPr>
-          </a:lstStyle>
-          <a:p>
-            <a:pPr marL="0" marR="0" lvl="0" indent="0" algn="l" defTabSz="914400" rtl="0" eaLnBrk="0" fontAlgn="base" latinLnBrk="0" hangingPunct="0">
-              <a:lnSpc>
-                <a:spcPct val="100000"/>
-              </a:lnSpc>
-              <a:spcBef>
-                <a:spcPct val="0"/>
-              </a:spcBef>
-              <a:spcAft>
-                <a:spcPct val="0"/>
-              </a:spcAft>
-              <a:buClrTx/>
-              <a:buSzTx/>
-              <a:buFontTx/>
-              <a:buNone/>
-              <a:tabLst/>
-            </a:pPr>
-            <a:r>
-              <a:rPr kumimoji="0" lang="en-US" altLang="en-US" sz="1800" b="0" i="0" u="none" strike="noStrike" cap="none" normalizeH="0" baseline="0">
-                <a:ln>
-                  <a:noFill/>
-                </a:ln>
-                <a:solidFill>
-                  <a:srgbClr val="000000"/>
-                </a:solidFill>
-                <a:effectLst/>
-                <a:latin typeface="Times New Roman" panose="02020603050405020304" pitchFamily="18" charset="0"/>
-                <a:cs typeface="Times New Roman" panose="02020603050405020304" pitchFamily="18" charset="0"/>
-              </a:rPr>
-              <a:t> </a:t>
-            </a:r>
-            <a:endParaRPr kumimoji="0" lang="en-US" altLang="en-US" sz="1800" b="0" i="0" u="none" strike="noStrike" cap="none" normalizeH="0" baseline="0">
-              <a:ln>
-                <a:noFill/>
-              </a:ln>
-              <a:solidFill>
-                <a:schemeClr val="tx1"/>
-              </a:solidFill>
-              <a:effectLst/>
-            </a:endParaRPr>
-          </a:p>
-          <a:p>
-            <a:pPr marL="0" marR="0" lvl="0" indent="0" algn="l" defTabSz="914400" rtl="0" eaLnBrk="0" fontAlgn="base" latinLnBrk="0" hangingPunct="0">
-              <a:lnSpc>
-                <a:spcPct val="100000"/>
-              </a:lnSpc>
-              <a:spcBef>
-                <a:spcPct val="0"/>
-              </a:spcBef>
-              <a:spcAft>
-                <a:spcPct val="0"/>
-              </a:spcAft>
-              <a:buClrTx/>
-              <a:buSzTx/>
-              <a:buFontTx/>
-              <a:buNone/>
-              <a:tabLst/>
-            </a:pPr>
-            <a:endParaRPr kumimoji="0" lang="en-US" altLang="en-US" sz="1800" b="0" i="0" u="none" strike="noStrike" cap="none" normalizeH="0" baseline="0">
-              <a:ln>
-                <a:noFill/>
-              </a:ln>
-              <a:solidFill>
-                <a:schemeClr val="tx1"/>
-              </a:solidFill>
-              <a:effectLst/>
-              <a:latin typeface="Arial" panose="020B0604020202020204" pitchFamily="34" charset="0"/>
-            </a:endParaRPr>
-          </a:p>
-        </p:txBody>
-      </p:sp>
-      <p:sp>
-        <p:nvSpPr>
           <p:cNvPr id="2" name="Title 2">
             <a:extLst>
               <a:ext uri="{FF2B5EF4-FFF2-40B4-BE49-F238E27FC236}">
@@ -18200,6 +16807,9 @@
             <a:pPr algn="l"/>
             <a:r>
               <a:rPr sz="1200" b="0">
+                <a:solidFill>
+                  <a:srgbClr val="0F172A"/>
+                </a:solidFill>
                 <a:latin typeface="Segoe UI"/>
               </a:rPr>
               <a:t>Live test results - Jun 22 2026 (all channels verified):</a:t>
@@ -18209,6 +16819,9 @@
             <a:pPr algn="l"/>
             <a:r>
               <a:rPr sz="1200" b="0">
+                <a:solidFill>
+                  <a:srgbClr val="0F172A"/>
+                </a:solidFill>
                 <a:latin typeface="Segoe UI"/>
               </a:rPr>
               <a:t>  TEST-001: GlobalTech $120k/18% -&gt; Approve (within policy)</a:t>
@@ -18218,6 +16831,9 @@
             <a:pPr algn="l"/>
             <a:r>
               <a:rPr sz="1200" b="0">
+                <a:solidFill>
+                  <a:srgbClr val="0F172A"/>
+                </a:solidFill>
                 <a:latin typeface="Segoe UI"/>
               </a:rPr>
               <a:t>  TEST-002: MegaCorp $350k/32%  -&gt; Approve with conditions (escalation)</a:t>
@@ -18227,6 +16843,9 @@
             <a:pPr algn="l"/>
             <a:r>
               <a:rPr sz="1200" b="0">
+                <a:solidFill>
+                  <a:srgbClr val="0F172A"/>
+                </a:solidFill>
                 <a:latin typeface="Segoe UI"/>
               </a:rPr>
               <a:t>  TEST-003: StartupXYZ $28k/45% -&gt; Reject (margin impact too high)</a:t>
@@ -18236,6 +16855,9 @@
             <a:pPr algn="l"/>
             <a:r>
               <a:rPr sz="1200" b="0">
+                <a:solidFill>
+                  <a:srgbClr val="0F172A"/>
+                </a:solidFill>
                 <a:latin typeface="Segoe UI"/>
               </a:rPr>
               <a:t>  TEST-004: Pharma $780k/22%    -&gt; Approve (enterprise, Finance pre-approved)</a:t>
@@ -18245,6 +16867,9 @@
             <a:pPr algn="l"/>
             <a:r>
               <a:rPr sz="1200" b="0">
+                <a:solidFill>
+                  <a:srgbClr val="0F172A"/>
+                </a:solidFill>
                 <a:latin typeface="Segoe UI"/>
               </a:rPr>
               <a:t>  Outlook Adaptive Card | Slack DM | Action Center  - all verified</a:t>
@@ -18257,6 +16882,9 @@
             <a:pPr algn="l"/>
             <a:r>
               <a:rPr sz="1200" b="0">
+                <a:solidFill>
+                  <a:srgbClr val="0F172A"/>
+                </a:solidFill>
                 <a:latin typeface="Segoe UI"/>
               </a:rPr>
               <a:t>Scenario 1 - Auto-approve (4% / $30k): zero human touches.</a:t>
@@ -18266,6 +16894,9 @@
             <a:pPr algn="l"/>
             <a:r>
               <a:rPr sz="1200" b="0">
+                <a:solidFill>
+                  <a:srgbClr val="0F172A"/>
+                </a:solidFill>
                 <a:latin typeface="Segoe UI"/>
               </a:rPr>
               <a:t>Scenario 2 - One approver (8% / $40k): Adaptive Card + Slack to Manager.</a:t>
@@ -18275,6 +16906,9 @@
             <a:pPr algn="l"/>
             <a:r>
               <a:rPr sz="1200" b="0">
+                <a:solidFill>
+                  <a:srgbClr val="0F172A"/>
+                </a:solidFill>
                 <a:latin typeface="Segoe UI"/>
               </a:rPr>
               <a:t>Scenario 3 - Full chain (30% / $1.2M): four sequential approvers; rejection</a:t>
@@ -18284,6 +16918,9 @@
             <a:pPr algn="l"/>
             <a:r>
               <a:rPr sz="1200" b="0">
+                <a:solidFill>
+                  <a:srgbClr val="0F172A"/>
+                </a:solidFill>
                 <a:latin typeface="Segoe UI"/>
               </a:rPr>
               <a:t>  short-circuits; full Data Fabric audit trail.</a:t>

</xml_diff>